<commit_message>
docs: Update Japanese demo script for Trusted Agent Store evaluation pipeline
- Revised the demo script to enhance clarity and detail regarding the evaluation pipeline steps, including PreCheck, Security Gate, and Auto-Decision.
- Improved descriptions of the evaluation process, emphasizing the dynamic nature of Trust Scores and the role of W&B Weave for traceability.
- Updated terminology for consistency and accuracy, ensuring better understanding for Japanese-speaking users.

These changes aim to provide a clearer and more comprehensive guide to the evaluation process within the Trusted Agent Store.
</commit_message>
<xml_diff>
--- a/docs/A2A_Protocol_Latest_2026.pptx
+++ b/docs/A2A_Protocol_Latest_2026.pptx
@@ -12,6 +12,9 @@
     <p:sldId id="260" r:id="rId6"/>
     <p:sldId id="261" r:id="rId7"/>
     <p:sldId id="262" r:id="rId8"/>
+    <p:sldId id="272" r:id="rId23"/>
+    <p:sldId id="273" r:id="rId24"/>
+    <p:sldId id="274" r:id="rId25"/>
     <p:sldId id="263" r:id="rId9"/>
     <p:sldId id="264" r:id="rId10"/>
     <p:sldId id="265" r:id="rId11"/>
@@ -120,272 +123,6 @@
     </a:lvl9pPr>
   </p:defaultTextStyle>
 </p:presentation>
-</file>
-
-<file path=ppt/charts/chart1.xml><?xml version="1.0" encoding="utf-8"?>
-<c:chartSpace xmlns:c="http://schemas.openxmlformats.org/drawingml/2006/chart" xmlns:a="http://schemas.openxmlformats.org/drawingml/2006/main" xmlns:r="http://schemas.openxmlformats.org/officeDocument/2006/relationships">
-  <c:date1904 val="0"/>
-  <c:roundedCorners val="1"/>
-  <c:chart>
-    <c:autoTitleDeleted val="1"/>
-    <c:plotArea>
-      <c:layout/>
-      <c:barChart>
-        <c:barDir val="col"/>
-        <c:grouping val="clustered"/>
-        <c:varyColors val="0"/>
-        <c:ser>
-          <c:idx val="0"/>
-          <c:order val="0"/>
-          <c:tx>
-            <c:strRef>
-              <c:f>Sheet1!$B$1</c:f>
-              <c:strCache>
-                <c:ptCount val="1"/>
-                <c:pt idx="0">
-                  <c:v>AIエージェント市場規模 ($B)</c:v>
-                </c:pt>
-              </c:strCache>
-            </c:strRef>
-          </c:tx>
-          <c:spPr>
-            <a:solidFill>
-              <a:srgbClr val="00A896"/>
-            </a:solidFill>
-            <a:effectLst/>
-          </c:spPr>
-          <c:invertIfNegative val="0"/>
-          <c:dLbls>
-            <c:numFmt formatCode="#,##0" sourceLinked="0"/>
-            <c:txPr>
-              <a:bodyPr/>
-              <a:lstStyle/>
-              <a:p>
-                <a:pPr>
-                  <a:defRPr b="0" i="0" strike="noStrike" sz="800" u="none">
-                    <a:solidFill>
-                      <a:srgbClr val="1E293B"/>
-                    </a:solidFill>
-                    <a:latin typeface="Arial"/>
-                  </a:defRPr>
-                </a:pPr>
-              </a:p>
-            </c:txPr>
-            <c:showLegendKey val="0"/>
-            <c:showVal val="1"/>
-            <c:showCatName val="0"/>
-            <c:showSerName val="0"/>
-            <c:showPercent val="0"/>
-            <c:showBubbleSize val="0"/>
-            <c:showLeaderLines val="0"/>
-          </c:dLbls>
-          <c:cat>
-            <c:multiLvlStrRef>
-              <c:f>Sheet1!$A$2:$A$8</c:f>
-              <c:multiLvlStrCache>
-                <c:ptCount val="7"/>
-                <c:lvl>
-                  <c:pt idx="0">
-                    <c:v>2024</c:v>
-                  </c:pt>
-                  <c:pt idx="1">
-                    <c:v>2025</c:v>
-                  </c:pt>
-                  <c:pt idx="2">
-                    <c:v>2026</c:v>
-                  </c:pt>
-                  <c:pt idx="3">
-                    <c:v>2027</c:v>
-                  </c:pt>
-                  <c:pt idx="4">
-                    <c:v>2028</c:v>
-                  </c:pt>
-                  <c:pt idx="5">
-                    <c:v>2029</c:v>
-                  </c:pt>
-                  <c:pt idx="6">
-                    <c:v>2030</c:v>
-                  </c:pt>
-                </c:lvl>
-              </c:multiLvlStrCache>
-            </c:multiLvlStrRef>
-          </c:cat>
-          <c:val>
-            <c:numRef>
-              <c:f>Sheet1!$B$2:$B$8</c:f>
-              <c:numCache>
-                <c:formatCode>General</c:formatCode>
-                <c:ptCount val="7"/>
-                <c:pt idx="0">
-                  <c:v>5.1</c:v>
-                </c:pt>
-                <c:pt idx="1">
-                  <c:v>7.6</c:v>
-                </c:pt>
-                <c:pt idx="2">
-                  <c:v>10.9</c:v>
-                </c:pt>
-                <c:pt idx="3">
-                  <c:v>21</c:v>
-                </c:pt>
-                <c:pt idx="4">
-                  <c:v>47</c:v>
-                </c:pt>
-                <c:pt idx="5">
-                  <c:v>101</c:v>
-                </c:pt>
-                <c:pt idx="6">
-                  <c:v>216</c:v>
-                </c:pt>
-              </c:numCache>
-            </c:numRef>
-          </c:val>
-        </c:ser>
-        <c:dLbls>
-          <c:numFmt formatCode="#,##0" sourceLinked="0"/>
-          <c:txPr>
-            <a:bodyPr/>
-            <a:lstStyle/>
-            <a:p>
-              <a:pPr>
-                <a:defRPr b="0" i="0" strike="noStrike" sz="800" u="none">
-                  <a:solidFill>
-                    <a:srgbClr val="1E293B"/>
-                  </a:solidFill>
-                  <a:latin typeface="Arial"/>
-                </a:defRPr>
-              </a:pPr>
-            </a:p>
-          </c:txPr>
-          <c:showLegendKey val="0"/>
-          <c:showVal val="1"/>
-          <c:showCatName val="0"/>
-          <c:showSerName val="0"/>
-          <c:showPercent val="0"/>
-          <c:showBubbleSize val="0"/>
-          <c:showLeaderLines val="0"/>
-        </c:dLbls>
-        <c:gapWidth val="150"/>
-        <c:overlap val="0"/>
-        <c:axId val="2094734554"/>
-        <c:axId val="2094734552"/>
-        <c:axId val="2094734556"/>
-      </c:barChart>
-      <c:catAx>
-        <c:axId val="2094734554"/>
-        <c:scaling>
-          <c:orientation val="minMax"/>
-        </c:scaling>
-        <c:delete val="0"/>
-        <c:axPos val="b"/>
-        <c:numFmt formatCode="General" sourceLinked="1"/>
-        <c:majorTickMark val="out"/>
-        <c:minorTickMark val="none"/>
-        <c:tickLblPos val="low"/>
-        <c:spPr>
-          <a:ln w="12700" cap="flat">
-            <a:solidFill>
-              <a:srgbClr val="888888"/>
-            </a:solidFill>
-            <a:prstDash val="solid"/>
-            <a:round/>
-          </a:ln>
-        </c:spPr>
-        <c:txPr>
-          <a:bodyPr/>
-          <a:lstStyle/>
-          <a:p>
-            <a:pPr>
-              <a:defRPr sz="900" b="0" i="0" u="none" strike="noStrike">
-                <a:solidFill>
-                  <a:srgbClr val="475569"/>
-                </a:solidFill>
-                <a:latin typeface="Arial"/>
-              </a:defRPr>
-            </a:pPr>
-            <a:endParaRPr lang="en-US"/>
-          </a:p>
-        </c:txPr>
-        <c:crossAx val="2094734552"/>
-        <c:crosses val="autoZero"/>
-        <c:auto val="1"/>
-        <c:lblAlgn val="ctr"/>
-        <c:noMultiLvlLbl val="1"/>
-      </c:catAx>
-      <c:valAx>
-        <c:axId val="2094734552"/>
-        <c:scaling>
-          <c:orientation val="minMax"/>
-        </c:scaling>
-        <c:delete val="0"/>
-        <c:axPos val="l"/>
-        <c:majorGridlines>
-          <c:spPr>
-            <a:ln w="6350" cap="flat">
-              <a:solidFill>
-                <a:srgbClr val="E2E8F0"/>
-              </a:solidFill>
-              <a:prstDash val="solid"/>
-              <a:round/>
-            </a:ln>
-          </c:spPr>
-        </c:majorGridlines>
-        <c:numFmt formatCode="General" sourceLinked="0"/>
-        <c:majorTickMark val="out"/>
-        <c:minorTickMark val="none"/>
-        <c:tickLblPos val="nextTo"/>
-        <c:spPr>
-          <a:ln w="12700" cap="flat">
-            <a:solidFill>
-              <a:srgbClr val="888888"/>
-            </a:solidFill>
-            <a:prstDash val="solid"/>
-            <a:round/>
-          </a:ln>
-        </c:spPr>
-        <c:txPr>
-          <a:bodyPr/>
-          <a:lstStyle/>
-          <a:p>
-            <a:pPr>
-              <a:defRPr sz="800" b="0" i="0" u="none" strike="noStrike">
-                <a:solidFill>
-                  <a:srgbClr val="475569"/>
-                </a:solidFill>
-                <a:latin typeface="Arial"/>
-              </a:defRPr>
-            </a:pPr>
-            <a:endParaRPr lang="en-US"/>
-          </a:p>
-        </c:txPr>
-        <c:crossAx val="2094734554"/>
-        <c:crosses val="autoZero"/>
-        <c:crossBetween val="between"/>
-      </c:valAx>
-      <c:spPr>
-        <a:noFill/>
-        <a:ln>
-          <a:noFill/>
-        </a:ln>
-        <a:effectLst/>
-      </c:spPr>
-    </c:plotArea>
-    <c:plotVisOnly val="1"/>
-    <c:dispBlanksAs val="span"/>
-  </c:chart>
-  <c:spPr>
-    <a:solidFill>
-      <a:srgbClr val="FFFFFF"/>
-    </a:solidFill>
-    <a:ln>
-      <a:noFill/>
-    </a:ln>
-    <a:effectLst/>
-  </c:spPr>
-  <c:externalData r:id="rId1">
-    <c:autoUpdate val="0"/>
-  </c:externalData>
-</c:chartSpace>
 </file>
 
 <file path=ppt/notesMasters/notesMaster1.xml><?xml version="1.0" encoding="utf-8"?>
@@ -2525,7 +2262,7 @@
       </p:sp>
       <p:pic>
         <p:nvPicPr>
-          <p:cNvPr id="4" name="Image 0" descr="preencoded.png">    </p:cNvPr>
+          <p:cNvPr id="4" name="Image 0" descr="preencoded.png"/>
           <p:cNvPicPr>
             <a:picLocks noChangeAspect="1"/>
           </p:cNvPicPr>
@@ -3926,7 +3663,7 @@
       </p:sp>
       <p:pic>
         <p:nvPicPr>
-          <p:cNvPr id="6" name="Image 0" descr="preencoded.png">    </p:cNvPr>
+          <p:cNvPr id="6" name="Image 0" descr="preencoded.png"/>
           <p:cNvPicPr>
             <a:picLocks noChangeAspect="1"/>
           </p:cNvPicPr>
@@ -4251,7 +3988,7 @@
       </p:sp>
       <p:pic>
         <p:nvPicPr>
-          <p:cNvPr id="11" name="Image 1" descr="preencoded.png">    </p:cNvPr>
+          <p:cNvPr id="11" name="Image 1" descr="preencoded.png"/>
           <p:cNvPicPr>
             <a:picLocks noChangeAspect="1"/>
           </p:cNvPicPr>
@@ -6014,22 +5751,6 @@
           </a:p>
         </p:txBody>
       </p:sp>
-      <p:graphicFrame>
-        <p:nvGraphicFramePr>
-          <p:cNvPr id="16" name="Chart 0" descr=""/>
-          <p:cNvGraphicFramePr/>
-          <p:nvPr/>
-        </p:nvGraphicFramePr>
-        <p:xfrm>
-          <a:off x="640080" y="2743200"/>
-          <a:ext cx="7863840" cy="1920240"/>
-        </p:xfrm>
-        <a:graphic xmlns:a="http://schemas.openxmlformats.org/drawingml/2006/main">
-          <a:graphicData uri="http://schemas.openxmlformats.org/drawingml/2006/chart">
-            <c:chart xmlns:c="http://schemas.openxmlformats.org/drawingml/2006/chart" r:id="rId1"/>
-          </a:graphicData>
-        </a:graphic>
-      </p:graphicFrame>
       <p:sp>
         <p:nvSpPr>
           <p:cNvPr id="17" name="Shape 14"/>
@@ -6604,7 +6325,7 @@
       </p:sp>
       <p:pic>
         <p:nvPicPr>
-          <p:cNvPr id="14" name="Image 0" descr="preencoded.png">    </p:cNvPr>
+          <p:cNvPr id="14" name="Image 0" descr="preencoded.png"/>
           <p:cNvPicPr>
             <a:picLocks noChangeAspect="1"/>
           </p:cNvPicPr>
@@ -6656,7 +6377,7 @@
                   <a:srgbClr val="065A82"/>
                 </a:solidFill>
               </a:rPr>
-              <a:t>カスタマーサポート自動化 — </a:t>
+              <a:t xml:space="preserve">カスタマーサポート自動化 — </a:t>
             </a:r>
             <a:pPr indent="0" marL="0">
               <a:buNone/>
@@ -6675,7 +6396,7 @@
       </p:sp>
       <p:pic>
         <p:nvPicPr>
-          <p:cNvPr id="16" name="Image 1" descr="preencoded.png">    </p:cNvPr>
+          <p:cNvPr id="16" name="Image 1" descr="preencoded.png"/>
           <p:cNvPicPr>
             <a:picLocks noChangeAspect="1"/>
           </p:cNvPicPr>
@@ -6727,7 +6448,7 @@
                   <a:srgbClr val="065A82"/>
                 </a:solidFill>
               </a:rPr>
-              <a:t>サプライチェーン最適化 — </a:t>
+              <a:t xml:space="preserve">サプライチェーン最適化 — </a:t>
             </a:r>
             <a:pPr indent="0" marL="0">
               <a:buNone/>
@@ -6746,7 +6467,7 @@
       </p:sp>
       <p:pic>
         <p:nvPicPr>
-          <p:cNvPr id="18" name="Image 2" descr="preencoded.png">    </p:cNvPr>
+          <p:cNvPr id="18" name="Image 2" descr="preencoded.png"/>
           <p:cNvPicPr>
             <a:picLocks noChangeAspect="1"/>
           </p:cNvPicPr>
@@ -6798,7 +6519,7 @@
                   <a:srgbClr val="065A82"/>
                 </a:solidFill>
               </a:rPr>
-              <a:t>金融リスク分析 — </a:t>
+              <a:t xml:space="preserve">金融リスク分析 — </a:t>
             </a:r>
             <a:pPr indent="0" marL="0">
               <a:buNone/>
@@ -6994,7 +6715,7 @@
       </p:sp>
       <p:pic>
         <p:nvPicPr>
-          <p:cNvPr id="5" name="Image 0" descr="preencoded.png">    </p:cNvPr>
+          <p:cNvPr id="5" name="Image 0" descr="preencoded.png"/>
           <p:cNvPicPr>
             <a:picLocks noChangeAspect="1"/>
           </p:cNvPicPr>
@@ -7101,7 +6822,7 @@
       </p:sp>
       <p:pic>
         <p:nvPicPr>
-          <p:cNvPr id="8" name="Image 1" descr="preencoded.png">    </p:cNvPr>
+          <p:cNvPr id="8" name="Image 1" descr="preencoded.png"/>
           <p:cNvPicPr>
             <a:picLocks noChangeAspect="1"/>
           </p:cNvPicPr>
@@ -7208,7 +6929,7 @@
       </p:sp>
       <p:pic>
         <p:nvPicPr>
-          <p:cNvPr id="11" name="Image 2" descr="preencoded.png">    </p:cNvPr>
+          <p:cNvPr id="11" name="Image 2" descr="preencoded.png"/>
           <p:cNvPicPr>
             <a:picLocks noChangeAspect="1"/>
           </p:cNvPicPr>
@@ -7315,7 +7036,7 @@
       </p:sp>
       <p:pic>
         <p:nvPicPr>
-          <p:cNvPr id="14" name="Image 3" descr="preencoded.png">    </p:cNvPr>
+          <p:cNvPr id="14" name="Image 3" descr="preencoded.png"/>
           <p:cNvPicPr>
             <a:picLocks noChangeAspect="1"/>
           </p:cNvPicPr>
@@ -7506,7 +7227,7 @@
       </p:sp>
       <p:pic>
         <p:nvPicPr>
-          <p:cNvPr id="4" name="Image 0" descr="preencoded.png">    </p:cNvPr>
+          <p:cNvPr id="4" name="Image 0" descr="preencoded.png"/>
           <p:cNvPicPr>
             <a:picLocks noChangeAspect="1"/>
           </p:cNvPicPr>
@@ -7569,7 +7290,7 @@
       </p:sp>
       <p:pic>
         <p:nvPicPr>
-          <p:cNvPr id="6" name="Image 1" descr="preencoded.png">    </p:cNvPr>
+          <p:cNvPr id="6" name="Image 1" descr="preencoded.png"/>
           <p:cNvPicPr>
             <a:picLocks noChangeAspect="1"/>
           </p:cNvPicPr>
@@ -7632,7 +7353,7 @@
       </p:sp>
       <p:pic>
         <p:nvPicPr>
-          <p:cNvPr id="8" name="Image 2" descr="preencoded.png">    </p:cNvPr>
+          <p:cNvPr id="8" name="Image 2" descr="preencoded.png"/>
           <p:cNvPicPr>
             <a:picLocks noChangeAspect="1"/>
           </p:cNvPicPr>
@@ -7695,7 +7416,7 @@
       </p:sp>
       <p:pic>
         <p:nvPicPr>
-          <p:cNvPr id="10" name="Image 3" descr="preencoded.png">    </p:cNvPr>
+          <p:cNvPr id="10" name="Image 3" descr="preencoded.png"/>
           <p:cNvPicPr>
             <a:picLocks noChangeAspect="1"/>
           </p:cNvPicPr>
@@ -7758,7 +7479,7 @@
       </p:sp>
       <p:pic>
         <p:nvPicPr>
-          <p:cNvPr id="12" name="Image 4" descr="preencoded.png">    </p:cNvPr>
+          <p:cNvPr id="12" name="Image 4" descr="preencoded.png"/>
           <p:cNvPicPr>
             <a:picLocks noChangeAspect="1"/>
           </p:cNvPicPr>
@@ -7858,6 +7579,2178 @@
           </a:solidFill>
           <a:ln/>
         </p:spPr>
+      </p:sp>
+    </p:spTree>
+  </p:cSld>
+  <p:clrMapOvr>
+    <a:masterClrMapping/>
+  </p:clrMapOvr>
+</p:sld>
+</file>
+
+<file path=ppt/slides/slide17.xml><?xml version="1.0" encoding="utf-8"?>
+<p:sld xmlns:a="http://schemas.openxmlformats.org/drawingml/2006/main" xmlns:r="http://schemas.openxmlformats.org/officeDocument/2006/relationships" xmlns:p="http://schemas.openxmlformats.org/presentationml/2006/main">
+  <p:cSld name="Slide 8 - Gemini Enterprise x Cloud Marketplace">
+    <p:bg>
+      <p:bgPr>
+        <a:solidFill>
+          <a:srgbClr val="F0F4F8"/>
+        </a:solidFill>
+      </p:bgPr>
+    </p:bg>
+    <p:spTree>
+      <p:nvGrpSpPr>
+        <p:cNvPr id="1" name=""/>
+        <p:cNvGrpSpPr/>
+        <p:nvPr/>
+      </p:nvGrpSpPr>
+      <p:grpSpPr>
+        <a:xfrm>
+          <a:off x="0" y="0"/>
+          <a:ext cx="0" cy="0"/>
+          <a:chOff x="0" y="0"/>
+          <a:chExt cx="0" cy="0"/>
+        </a:xfrm>
+      </p:grpSpPr>
+      <p:sp>
+        <p:nvSpPr>
+          <p:cNvPr id="2" name="Shape 0"/>
+          <p:cNvSpPr/>
+          <p:nvPr/>
+        </p:nvSpPr>
+        <p:spPr>
+          <a:xfrm>
+            <a:off x="0" y="0"/>
+            <a:ext cx="9144000" cy="54864"/>
+          </a:xfrm>
+          <a:prstGeom prst="rect">
+            <a:avLst/>
+          </a:prstGeom>
+          <a:solidFill>
+            <a:srgbClr val="00A896"/>
+          </a:solidFill>
+          <a:ln/>
+        </p:spPr>
+      </p:sp>
+      <p:sp>
+        <p:nvSpPr>
+          <p:cNvPr id="3" name="Text 1"/>
+          <p:cNvSpPr/>
+          <p:nvPr/>
+        </p:nvSpPr>
+        <p:spPr>
+          <a:xfrm>
+            <a:off x="640080" y="274320"/>
+            <a:ext cx="8229600" cy="640080"/>
+          </a:xfrm>
+          <a:prstGeom prst="rect">
+            <a:avLst/>
+          </a:prstGeom>
+          <a:noFill/>
+          <a:ln/>
+        </p:spPr>
+        <p:txBody>
+          <a:bodyPr wrap="square" lIns="0" tIns="0" rIns="0" bIns="0" rtlCol="0" anchor="ctr"/>
+          <a:lstStyle/>
+          <a:p>
+            <a:pPr indent="0" marL="0">
+              <a:buNone/>
+            </a:pPr>
+            <a:r>
+              <a:rPr lang="en-US" sz="2200" b="1" dirty="0">
+                <a:solidFill>
+                  <a:srgbClr val="1E2761"/>
+                </a:solidFill>
+                <a:latin typeface="Georgia" pitchFamily="34" charset="0"/>
+                <a:ea typeface="Georgia" pitchFamily="34" charset="-122"/>
+                <a:cs typeface="Georgia" pitchFamily="34" charset="-120"/>
+              </a:rPr>
+              <a:t>Gemini Enterprise × Cloud Marketplace の関係</a:t>
+            </a:r>
+            <a:endParaRPr lang="en-US" sz="2600" dirty="0"/>
+          </a:p>
+        </p:txBody>
+      </p:sp>
+      <p:sp>
+        <p:nvSpPr>
+          <p:cNvPr id="4" name="Shape 2"/>
+          <p:cNvSpPr/>
+          <p:nvPr/>
+        </p:nvSpPr>
+        <p:spPr>
+          <a:xfrm>
+            <a:off x="640080" y="1051560"/>
+            <a:ext cx="7863840" cy="731520"/>
+          </a:xfrm>
+          <a:prstGeom prst="rect">
+            <a:avLst/>
+          </a:prstGeom>
+          <a:solidFill>
+            <a:srgbClr val="065A82"/>
+          </a:solidFill>
+          <a:ln/>
+          <a:effectLst>
+            <a:outerShdw sx="100000" sy="100000" kx="0" ky="0" algn="bl" rotWithShape="0" blurRad="76200" dist="25400" dir="8100000">
+              <a:srgbClr val="000000">
+                <a:alpha val="12000"/>
+              </a:srgbClr>
+            </a:outerShdw>
+          </a:effectLst>
+        </p:spPr>
+      </p:sp>
+      <p:sp>
+        <p:nvSpPr>
+          <p:cNvPr id="5" name="Text 3"/>
+          <p:cNvSpPr/>
+          <p:nvPr/>
+        </p:nvSpPr>
+        <p:spPr>
+          <a:xfrm>
+            <a:off x="914400" y="1051560"/>
+            <a:ext cx="7315200" cy="731520"/>
+          </a:xfrm>
+          <a:prstGeom prst="rect">
+            <a:avLst/>
+          </a:prstGeom>
+          <a:noFill/>
+          <a:ln/>
+        </p:spPr>
+        <p:txBody>
+          <a:bodyPr wrap="square" lIns="0" tIns="0" rIns="0" bIns="0" rtlCol="0" anchor="ctr"/>
+          <a:lstStyle/>
+          <a:p>
+            <a:pPr indent="0" marL="0">
+              <a:buNone/>
+            </a:pPr>
+            <a:r>
+              <a:rPr lang="en-US" sz="1300" dirty="0">
+                <a:solidFill>
+                  <a:srgbClr val="FFFFFF"/>
+                </a:solidFill>
+                <a:latin typeface="Calibri" pitchFamily="34" charset="0"/>
+                <a:ea typeface="Calibri" pitchFamily="34" charset="-122"/>
+                <a:cs typeface="Calibri" pitchFamily="34" charset="-120"/>
+              </a:rPr>
+              <a:t>Cloud MarketplaceのAIエージェントはA2Aプロトコルで通信し、Gemini Enterpriseに統合されてGoogleから一元課金される</a:t>
+            </a:r>
+            <a:endParaRPr lang="en-US" sz="1300" dirty="0"/>
+          </a:p>
+        </p:txBody>
+      </p:sp>
+      <p:sp>
+        <p:nvSpPr>
+          <p:cNvPr id="6" name="Shape 4"/>
+          <p:cNvSpPr/>
+          <p:nvPr/>
+        </p:nvSpPr>
+        <p:spPr>
+          <a:xfrm>
+            <a:off x="457200" y="1965960"/>
+            <a:ext cx="1965960" cy="2286000"/>
+          </a:xfrm>
+          <a:prstGeom prst="rect">
+            <a:avLst/>
+          </a:prstGeom>
+          <a:solidFill>
+            <a:srgbClr val="FFFFFF"/>
+          </a:solidFill>
+          <a:ln/>
+          <a:effectLst>
+            <a:outerShdw sx="100000" sy="100000" kx="0" ky="0" algn="bl" rotWithShape="0" blurRad="76200" dist="25400" dir="8100000">
+              <a:srgbClr val="000000">
+                <a:alpha val="12000"/>
+              </a:srgbClr>
+            </a:outerShdw>
+          </a:effectLst>
+        </p:spPr>
+      </p:sp>
+      <p:pic>
+        <p:nvPicPr>
+          <p:cNvPr id="7" name="Image 0" descr="preencoded.png"/>
+          <p:cNvPicPr>
+            <a:picLocks noChangeAspect="1"/>
+          </p:cNvPicPr>
+          <p:nvPr/>
+        </p:nvPicPr>
+        <p:blipFill>
+          <a:blip r:embed="rId1"/>
+          <a:stretch>
+            <a:fillRect/>
+          </a:stretch>
+        </p:blipFill>
+        <p:spPr>
+          <a:xfrm>
+            <a:off x="1143000" y="2103120"/>
+            <a:ext cx="457200" cy="457200"/>
+          </a:xfrm>
+          <a:prstGeom prst="rect">
+            <a:avLst/>
+          </a:prstGeom>
+        </p:spPr>
+      </p:pic>
+      <p:sp>
+        <p:nvSpPr>
+          <p:cNvPr id="8" name="Text 5"/>
+          <p:cNvSpPr/>
+          <p:nvPr/>
+        </p:nvSpPr>
+        <p:spPr>
+          <a:xfrm>
+            <a:off x="548640" y="2606040"/>
+            <a:ext cx="1783080" cy="1554480"/>
+          </a:xfrm>
+          <a:prstGeom prst="rect">
+            <a:avLst/>
+          </a:prstGeom>
+          <a:noFill/>
+          <a:ln/>
+        </p:spPr>
+        <p:txBody>
+          <a:bodyPr wrap="square" lIns="0" tIns="0" rIns="0" bIns="0" rtlCol="0" anchor="t"/>
+          <a:lstStyle/>
+          <a:p>
+            <a:pPr algn="ctr" indent="0" marL="0">
+              <a:buNone/>
+            </a:pPr>
+            <a:r>
+              <a:rPr lang="en-US" sz="1200" b="1" dirty="0">
+                <a:solidFill>
+                  <a:srgbClr val="065A82"/>
+                </a:solidFill>
+              </a:rPr>
+              <a:t>Agent Card</a:t>
+            </a:r>
+            <a:endParaRPr lang="en-US" sz="1200" dirty="0"/>
+          </a:p>
+          <a:p>
+            <a:pPr algn="ctr" indent="0" marL="0">
+              <a:buNone/>
+            </a:pPr>
+            <a:r>
+              <a:rPr lang="en-US" sz="1000" b="1" dirty="0">
+                <a:solidFill>
+                  <a:srgbClr val="00A896"/>
+                </a:solidFill>
+              </a:rPr>
+              <a:t>(A2A仕様準拠)</a:t>
+            </a:r>
+            <a:endParaRPr lang="en-US" sz="1200" dirty="0"/>
+          </a:p>
+          <a:p>
+            <a:pPr algn="ctr" indent="0" marL="0">
+              <a:buNone/>
+            </a:pPr>
+            <a:endParaRPr lang="en-US" sz="600" dirty="0"/>
+          </a:p>
+          <a:p>
+            <a:pPr algn="ctr" indent="0" marL="0">
+              <a:buNone/>
+            </a:pPr>
+            <a:r>
+              <a:rPr lang="en-US" sz="1000" dirty="0">
+                <a:solidFill>
+                  <a:srgbClr val="475569"/>
+                </a:solidFill>
+              </a:rPr>
+              <a:t>JSON形式でエージェントの</a:t>
+            </a:r>
+            <a:endParaRPr lang="en-US" sz="1200" dirty="0"/>
+          </a:p>
+          <a:p>
+            <a:pPr algn="ctr" indent="0" marL="0">
+              <a:buNone/>
+            </a:pPr>
+            <a:r>
+              <a:rPr lang="en-US" sz="1000" dirty="0">
+                <a:solidFill>
+                  <a:srgbClr val="475569"/>
+                </a:solidFill>
+              </a:rPr>
+              <a:t>能力を定義・宣言</a:t>
+            </a:r>
+            <a:endParaRPr lang="en-US" sz="1200" dirty="0"/>
+          </a:p>
+          <a:p>
+            <a:pPr algn="ctr" indent="0" marL="0">
+              <a:buNone/>
+            </a:pPr>
+            <a:r>
+              <a:rPr lang="en-US" sz="1000" dirty="0">
+                <a:solidFill>
+                  <a:srgbClr val="475569"/>
+                </a:solidFill>
+              </a:rPr>
+              <a:t>自社ホスト+GCS登録</a:t>
+            </a:r>
+            <a:endParaRPr lang="en-US" sz="1200" dirty="0"/>
+          </a:p>
+          <a:p>
+            <a:pPr algn="ctr" indent="0" marL="0">
+              <a:buNone/>
+            </a:pPr>
+            <a:r>
+              <a:rPr lang="en-US" sz="1000" dirty="0">
+                <a:solidFill>
+                  <a:srgbClr val="475569"/>
+                </a:solidFill>
+              </a:rPr>
+              <a:t>他エージェントとの連携基盤</a:t>
+            </a:r>
+            <a:endParaRPr lang="en-US" sz="1200" dirty="0"/>
+          </a:p>
+        </p:txBody>
+      </p:sp>
+      <p:sp>
+        <p:nvSpPr>
+          <p:cNvPr id="9" name="Shape 6"/>
+          <p:cNvSpPr/>
+          <p:nvPr/>
+        </p:nvSpPr>
+        <p:spPr>
+          <a:xfrm>
+            <a:off x="2606040" y="1965960"/>
+            <a:ext cx="1965960" cy="2286000"/>
+          </a:xfrm>
+          <a:prstGeom prst="rect">
+            <a:avLst/>
+          </a:prstGeom>
+          <a:solidFill>
+            <a:srgbClr val="FFFFFF"/>
+          </a:solidFill>
+          <a:ln/>
+          <a:effectLst>
+            <a:outerShdw sx="100000" sy="100000" kx="0" ky="0" algn="bl" rotWithShape="0" blurRad="76200" dist="25400" dir="8100000">
+              <a:srgbClr val="000000">
+                <a:alpha val="12000"/>
+              </a:srgbClr>
+            </a:outerShdw>
+          </a:effectLst>
+        </p:spPr>
+      </p:sp>
+      <p:pic>
+        <p:nvPicPr>
+          <p:cNvPr id="10" name="Image 1" descr="preencoded.png"/>
+          <p:cNvPicPr>
+            <a:picLocks noChangeAspect="1"/>
+          </p:cNvPicPr>
+          <p:nvPr/>
+        </p:nvPicPr>
+        <p:blipFill>
+          <a:blip r:embed="rId2"/>
+          <a:stretch>
+            <a:fillRect/>
+          </a:stretch>
+        </p:blipFill>
+        <p:spPr>
+          <a:xfrm>
+            <a:off x="3291840" y="2103120"/>
+            <a:ext cx="457200" cy="457200"/>
+          </a:xfrm>
+          <a:prstGeom prst="rect">
+            <a:avLst/>
+          </a:prstGeom>
+        </p:spPr>
+      </p:pic>
+      <p:sp>
+        <p:nvSpPr>
+          <p:cNvPr id="11" name="Text 7"/>
+          <p:cNvSpPr/>
+          <p:nvPr/>
+        </p:nvSpPr>
+        <p:spPr>
+          <a:xfrm>
+            <a:off x="2697480" y="2606040"/>
+            <a:ext cx="1783080" cy="1554480"/>
+          </a:xfrm>
+          <a:prstGeom prst="rect">
+            <a:avLst/>
+          </a:prstGeom>
+          <a:noFill/>
+          <a:ln/>
+        </p:spPr>
+        <p:txBody>
+          <a:bodyPr wrap="square" lIns="0" tIns="0" rIns="0" bIns="0" rtlCol="0" anchor="t"/>
+          <a:lstStyle/>
+          <a:p>
+            <a:pPr algn="ctr" indent="0" marL="0">
+              <a:buNone/>
+            </a:pPr>
+            <a:r>
+              <a:rPr lang="en-US" sz="1200" b="1" dirty="0">
+                <a:solidFill>
+                  <a:srgbClr val="065A82"/>
+                </a:solidFill>
+              </a:rPr>
+              <a:t>Gemini Enterprise</a:t>
+            </a:r>
+            <a:endParaRPr lang="en-US" sz="1200" dirty="0"/>
+          </a:p>
+          <a:p>
+            <a:pPr algn="ctr" indent="0" marL="0">
+              <a:buNone/>
+            </a:pPr>
+            <a:r>
+              <a:rPr lang="en-US" sz="1000" b="1" dirty="0">
+                <a:solidFill>
+                  <a:srgbClr val="00A896"/>
+                </a:solidFill>
+              </a:rPr>
+              <a:t>(統合先)</a:t>
+            </a:r>
+            <a:endParaRPr lang="en-US" sz="1200" dirty="0"/>
+          </a:p>
+          <a:p>
+            <a:pPr algn="ctr" indent="0" marL="0">
+              <a:buNone/>
+            </a:pPr>
+            <a:endParaRPr lang="en-US" sz="600" dirty="0"/>
+          </a:p>
+          <a:p>
+            <a:pPr algn="ctr" indent="0" marL="0">
+              <a:buNone/>
+            </a:pPr>
+            <a:r>
+              <a:rPr lang="en-US" sz="1000" dirty="0">
+                <a:solidFill>
+                  <a:srgbClr val="475569"/>
+                </a:solidFill>
+              </a:rPr>
+              <a:t>Cloud Console UIから</a:t>
+            </a:r>
+            <a:endParaRPr lang="en-US" sz="1200" dirty="0"/>
+          </a:p>
+          <a:p>
+            <a:pPr algn="ctr" indent="0" marL="0">
+              <a:buNone/>
+            </a:pPr>
+            <a:r>
+              <a:rPr lang="en-US" sz="1000" dirty="0">
+                <a:solidFill>
+                  <a:srgbClr val="475569"/>
+                </a:solidFill>
+              </a:rPr>
+              <a:t>検索・追加（8ステップ）</a:t>
+            </a:r>
+            <a:endParaRPr lang="en-US" sz="1200" dirty="0"/>
+          </a:p>
+          <a:p>
+            <a:pPr algn="ctr" indent="0" marL="0">
+              <a:buNone/>
+            </a:pPr>
+            <a:r>
+              <a:rPr lang="en-US" sz="1000" dirty="0">
+                <a:solidFill>
+                  <a:srgbClr val="475569"/>
+                </a:solidFill>
+              </a:rPr>
+              <a:t>Google Cloud上で実行</a:t>
+            </a:r>
+            <a:endParaRPr lang="en-US" sz="1200" dirty="0"/>
+          </a:p>
+          <a:p>
+            <a:pPr algn="ctr" indent="0" marL="0">
+              <a:buNone/>
+            </a:pPr>
+            <a:r>
+              <a:rPr lang="en-US" sz="1000" dirty="0">
+                <a:solidFill>
+                  <a:srgbClr val="475569"/>
+                </a:solidFill>
+              </a:rPr>
+              <a:t>Googleから一元課金</a:t>
+            </a:r>
+            <a:endParaRPr lang="en-US" sz="1200" dirty="0"/>
+          </a:p>
+        </p:txBody>
+      </p:sp>
+      <p:sp>
+        <p:nvSpPr>
+          <p:cNvPr id="12" name="Shape 8"/>
+          <p:cNvSpPr/>
+          <p:nvPr/>
+        </p:nvSpPr>
+        <p:spPr>
+          <a:xfrm>
+            <a:off x="4754880" y="1965960"/>
+            <a:ext cx="1965960" cy="2286000"/>
+          </a:xfrm>
+          <a:prstGeom prst="rect">
+            <a:avLst/>
+          </a:prstGeom>
+          <a:solidFill>
+            <a:srgbClr val="FFFFFF"/>
+          </a:solidFill>
+          <a:ln/>
+          <a:effectLst>
+            <a:outerShdw sx="100000" sy="100000" kx="0" ky="0" algn="bl" rotWithShape="0" blurRad="76200" dist="25400" dir="8100000">
+              <a:srgbClr val="000000">
+                <a:alpha val="12000"/>
+              </a:srgbClr>
+            </a:outerShdw>
+          </a:effectLst>
+        </p:spPr>
+      </p:sp>
+      <p:pic>
+        <p:nvPicPr>
+          <p:cNvPr id="13" name="Image 2" descr="preencoded.png"/>
+          <p:cNvPicPr>
+            <a:picLocks noChangeAspect="1"/>
+          </p:cNvPicPr>
+          <p:nvPr/>
+        </p:nvPicPr>
+        <p:blipFill>
+          <a:blip r:embed="rId3"/>
+          <a:stretch>
+            <a:fillRect/>
+          </a:stretch>
+        </p:blipFill>
+        <p:spPr>
+          <a:xfrm>
+            <a:off x="5440680" y="2103120"/>
+            <a:ext cx="457200" cy="457200"/>
+          </a:xfrm>
+          <a:prstGeom prst="rect">
+            <a:avLst/>
+          </a:prstGeom>
+        </p:spPr>
+      </p:pic>
+      <p:sp>
+        <p:nvSpPr>
+          <p:cNvPr id="14" name="Text 9"/>
+          <p:cNvSpPr/>
+          <p:nvPr/>
+        </p:nvSpPr>
+        <p:spPr>
+          <a:xfrm>
+            <a:off x="4846320" y="2606040"/>
+            <a:ext cx="1783080" cy="1554480"/>
+          </a:xfrm>
+          <a:prstGeom prst="rect">
+            <a:avLst/>
+          </a:prstGeom>
+          <a:noFill/>
+          <a:ln/>
+        </p:spPr>
+        <p:txBody>
+          <a:bodyPr wrap="square" lIns="0" tIns="0" rIns="0" bIns="0" rtlCol="0" anchor="t"/>
+          <a:lstStyle/>
+          <a:p>
+            <a:pPr algn="ctr" indent="0" marL="0">
+              <a:buNone/>
+            </a:pPr>
+            <a:r>
+              <a:rPr lang="en-US" sz="1200" b="1" dirty="0">
+                <a:solidFill>
+                  <a:srgbClr val="065A82"/>
+                </a:solidFill>
+              </a:rPr>
+              <a:t>Marketplace</a:t>
+            </a:r>
+            <a:endParaRPr lang="en-US" sz="1200" dirty="0"/>
+          </a:p>
+          <a:p>
+            <a:pPr algn="ctr" indent="0" marL="0">
+              <a:buNone/>
+            </a:pPr>
+            <a:r>
+              <a:rPr lang="en-US" sz="1000" b="1" dirty="0">
+                <a:solidFill>
+                  <a:srgbClr val="00A896"/>
+                </a:solidFill>
+              </a:rPr>
+              <a:t>(パートナー登録・公開)</a:t>
+            </a:r>
+            <a:endParaRPr lang="en-US" sz="1200" dirty="0"/>
+          </a:p>
+          <a:p>
+            <a:pPr algn="ctr" indent="0" marL="0">
+              <a:buNone/>
+            </a:pPr>
+            <a:endParaRPr lang="en-US" sz="600" dirty="0"/>
+          </a:p>
+          <a:p>
+            <a:pPr algn="ctr" indent="0" marL="0">
+              <a:buNone/>
+            </a:pPr>
+            <a:r>
+              <a:rPr lang="en-US" sz="1000" dirty="0">
+                <a:solidFill>
+                  <a:srgbClr val="475569"/>
+                </a:solidFill>
+              </a:rPr>
+              <a:t>Producer Portalで登録</a:t>
+            </a:r>
+            <a:endParaRPr lang="en-US" sz="1200" dirty="0"/>
+          </a:p>
+          <a:p>
+            <a:pPr algn="ctr" indent="0" marL="0">
+              <a:buNone/>
+            </a:pPr>
+            <a:r>
+              <a:rPr lang="en-US" sz="1000" dirty="0">
+                <a:solidFill>
+                  <a:srgbClr val="475569"/>
+                </a:solidFill>
+              </a:rPr>
+              <a:t>無料/サブスク/従量制</a:t>
+            </a:r>
+            <a:endParaRPr lang="en-US" sz="1200" dirty="0"/>
+          </a:p>
+          <a:p>
+            <a:pPr algn="ctr" indent="0" marL="0">
+              <a:buNone/>
+            </a:pPr>
+            <a:r>
+              <a:rPr lang="en-US" sz="1000" dirty="0">
+                <a:solidFill>
+                  <a:srgbClr val="475569"/>
+                </a:solidFill>
+              </a:rPr>
+              <a:t>Google認証+審査後に公開</a:t>
+            </a:r>
+            <a:endParaRPr lang="en-US" sz="1200" dirty="0"/>
+          </a:p>
+          <a:p>
+            <a:pPr algn="ctr" indent="0" marL="0">
+              <a:buNone/>
+            </a:pPr>
+            <a:r>
+              <a:rPr lang="en-US" sz="1000" dirty="0">
+                <a:solidFill>
+                  <a:srgbClr val="475569"/>
+                </a:solidFill>
+              </a:rPr>
+              <a:t>Agent Card登録が必須</a:t>
+            </a:r>
+            <a:endParaRPr lang="en-US" sz="1200" dirty="0"/>
+          </a:p>
+        </p:txBody>
+      </p:sp>
+      <p:sp>
+        <p:nvSpPr>
+          <p:cNvPr id="15" name="Shape 10"/>
+          <p:cNvSpPr/>
+          <p:nvPr/>
+        </p:nvSpPr>
+        <p:spPr>
+          <a:xfrm>
+            <a:off x="6903720" y="1965960"/>
+            <a:ext cx="1965960" cy="2286000"/>
+          </a:xfrm>
+          <a:prstGeom prst="rect">
+            <a:avLst/>
+          </a:prstGeom>
+          <a:solidFill>
+            <a:srgbClr val="FFFFFF"/>
+          </a:solidFill>
+          <a:ln/>
+          <a:effectLst>
+            <a:outerShdw sx="100000" sy="100000" kx="0" ky="0" algn="bl" rotWithShape="0" blurRad="76200" dist="25400" dir="8100000">
+              <a:srgbClr val="000000">
+                <a:alpha val="12000"/>
+              </a:srgbClr>
+            </a:outerShdw>
+          </a:effectLst>
+        </p:spPr>
+      </p:sp>
+      <p:pic>
+        <p:nvPicPr>
+          <p:cNvPr id="16" name="Image 3" descr="preencoded.png"/>
+          <p:cNvPicPr>
+            <a:picLocks noChangeAspect="1"/>
+          </p:cNvPicPr>
+          <p:nvPr/>
+        </p:nvPicPr>
+        <p:blipFill>
+          <a:blip r:embed="rId4"/>
+          <a:stretch>
+            <a:fillRect/>
+          </a:stretch>
+        </p:blipFill>
+        <p:spPr>
+          <a:xfrm>
+            <a:off x="7589520" y="2103120"/>
+            <a:ext cx="457200" cy="457200"/>
+          </a:xfrm>
+          <a:prstGeom prst="rect">
+            <a:avLst/>
+          </a:prstGeom>
+        </p:spPr>
+      </p:pic>
+      <p:sp>
+        <p:nvSpPr>
+          <p:cNvPr id="17" name="Text 11"/>
+          <p:cNvSpPr/>
+          <p:nvPr/>
+        </p:nvSpPr>
+        <p:spPr>
+          <a:xfrm>
+            <a:off x="6995160" y="2606040"/>
+            <a:ext cx="1783080" cy="1554480"/>
+          </a:xfrm>
+          <a:prstGeom prst="rect">
+            <a:avLst/>
+          </a:prstGeom>
+          <a:noFill/>
+          <a:ln/>
+        </p:spPr>
+        <p:txBody>
+          <a:bodyPr wrap="square" lIns="0" tIns="0" rIns="0" bIns="0" rtlCol="0" anchor="t"/>
+          <a:lstStyle/>
+          <a:p>
+            <a:pPr algn="ctr" indent="0" marL="0">
+              <a:buNone/>
+            </a:pPr>
+            <a:r>
+              <a:rPr lang="en-US" sz="1200" b="1" dirty="0">
+                <a:solidFill>
+                  <a:srgbClr val="065A82"/>
+                </a:solidFill>
+              </a:rPr>
+              <a:t>A2A通信</a:t>
+            </a:r>
+            <a:endParaRPr lang="en-US" sz="1200" dirty="0"/>
+          </a:p>
+          <a:p>
+            <a:pPr algn="ctr" indent="0" marL="0">
+              <a:buNone/>
+            </a:pPr>
+            <a:r>
+              <a:rPr lang="en-US" sz="1000" b="1" dirty="0">
+                <a:solidFill>
+                  <a:srgbClr val="00A896"/>
+                </a:solidFill>
+              </a:rPr>
+              <a:t>(エージェント間連携)</a:t>
+            </a:r>
+            <a:endParaRPr lang="en-US" sz="1200" dirty="0"/>
+          </a:p>
+          <a:p>
+            <a:pPr algn="ctr" indent="0" marL="0">
+              <a:buNone/>
+            </a:pPr>
+            <a:endParaRPr lang="en-US" sz="600" dirty="0"/>
+          </a:p>
+          <a:p>
+            <a:pPr algn="ctr" indent="0" marL="0">
+              <a:buNone/>
+            </a:pPr>
+            <a:r>
+              <a:rPr lang="en-US" sz="1000" dirty="0">
+                <a:solidFill>
+                  <a:srgbClr val="475569"/>
+                </a:solidFill>
+              </a:rPr>
+              <a:t>Agent Cardで能力発見</a:t>
+            </a:r>
+            <a:endParaRPr lang="en-US" sz="1200" dirty="0"/>
+          </a:p>
+          <a:p>
+            <a:pPr algn="ctr" indent="0" marL="0">
+              <a:buNone/>
+            </a:pPr>
+            <a:r>
+              <a:rPr lang="en-US" sz="1000" dirty="0">
+                <a:solidFill>
+                  <a:srgbClr val="475569"/>
+                </a:solidFill>
+              </a:rPr>
+              <a:t>タスク委譲・協調処理</a:t>
+            </a:r>
+            <a:endParaRPr lang="en-US" sz="1200" dirty="0"/>
+          </a:p>
+          <a:p>
+            <a:pPr algn="ctr" indent="0" marL="0">
+              <a:buNone/>
+            </a:pPr>
+            <a:r>
+              <a:rPr lang="en-US" sz="1000" dirty="0">
+                <a:solidFill>
+                  <a:srgbClr val="475569"/>
+                </a:solidFill>
+              </a:rPr>
+              <a:t>HTTP/JSON-RPC + gRPC</a:t>
+            </a:r>
+            <a:endParaRPr lang="en-US" sz="1200" dirty="0"/>
+          </a:p>
+          <a:p>
+            <a:pPr algn="ctr" indent="0" marL="0">
+              <a:buNone/>
+            </a:pPr>
+            <a:r>
+              <a:rPr lang="en-US" sz="1000" dirty="0">
+                <a:solidFill>
+                  <a:srgbClr val="475569"/>
+                </a:solidFill>
+              </a:rPr>
+              <a:t>マルチベンダー相互運用</a:t>
+            </a:r>
+            <a:endParaRPr lang="en-US" sz="1200" dirty="0"/>
+          </a:p>
+        </p:txBody>
+      </p:sp>
+      <p:sp>
+        <p:nvSpPr>
+          <p:cNvPr id="18" name="Shape 12"/>
+          <p:cNvSpPr/>
+          <p:nvPr/>
+        </p:nvSpPr>
+        <p:spPr>
+          <a:xfrm>
+            <a:off x="640080" y="4389120"/>
+            <a:ext cx="7863840" cy="320040"/>
+          </a:xfrm>
+          <a:prstGeom prst="rect">
+            <a:avLst/>
+          </a:prstGeom>
+          <a:solidFill>
+            <a:srgbClr val="FFFFFF"/>
+          </a:solidFill>
+          <a:ln/>
+          <a:effectLst>
+            <a:outerShdw sx="100000" sy="100000" kx="0" ky="0" algn="bl" rotWithShape="0" blurRad="76200" dist="25400" dir="8100000">
+              <a:srgbClr val="000000">
+                <a:alpha val="12000"/>
+              </a:srgbClr>
+            </a:outerShdw>
+          </a:effectLst>
+        </p:spPr>
+      </p:sp>
+      <p:sp>
+        <p:nvSpPr>
+          <p:cNvPr id="19" name="Text 13"/>
+          <p:cNvSpPr/>
+          <p:nvPr/>
+        </p:nvSpPr>
+        <p:spPr>
+          <a:xfrm>
+            <a:off x="822960" y="4389120"/>
+            <a:ext cx="7498080" cy="320040"/>
+          </a:xfrm>
+          <a:prstGeom prst="rect">
+            <a:avLst/>
+          </a:prstGeom>
+          <a:noFill/>
+          <a:ln/>
+        </p:spPr>
+        <p:txBody>
+          <a:bodyPr wrap="square" lIns="0" tIns="0" rIns="0" bIns="0" rtlCol="0" anchor="ctr"/>
+          <a:lstStyle/>
+          <a:p>
+            <a:pPr indent="0" marL="0">
+              <a:buNone/>
+            </a:pPr>
+            <a:r>
+              <a:rPr lang="en-US" sz="1100" b="1" dirty="0">
+                <a:solidFill>
+                  <a:srgbClr val="065A82"/>
+                </a:solidFill>
+                <a:latin typeface="Calibri" pitchFamily="34" charset="0"/>
+                <a:ea typeface="Calibri" pitchFamily="34" charset="-122"/>
+                <a:cs typeface="Calibri" pitchFamily="34" charset="-120"/>
+              </a:rPr>
+              <a:t>Agent CardがA2Aの「名刺」として機能 → Marketplace経由でGemini Enterpriseユーザーにエージェントを公開・課金</a:t>
+            </a:r>
+            <a:endParaRPr lang="en-US" sz="1100" dirty="0"/>
+          </a:p>
+        </p:txBody>
+      </p:sp>
+      <p:sp>
+        <p:nvSpPr>
+          <p:cNvPr id="20" name="Shape 14"/>
+          <p:cNvSpPr/>
+          <p:nvPr/>
+        </p:nvSpPr>
+        <p:spPr>
+          <a:xfrm>
+            <a:off x="0" y="4754880"/>
+            <a:ext cx="9144000" cy="388620"/>
+          </a:xfrm>
+          <a:prstGeom prst="rect">
+            <a:avLst/>
+          </a:prstGeom>
+          <a:solidFill>
+            <a:srgbClr val="1E2761"/>
+          </a:solidFill>
+          <a:ln/>
+        </p:spPr>
+      </p:sp>
+      <p:sp>
+        <p:nvSpPr>
+          <p:cNvPr id="21" name="Text 15"/>
+          <p:cNvSpPr/>
+          <p:nvPr/>
+        </p:nvSpPr>
+        <p:spPr>
+          <a:xfrm>
+            <a:off x="457200" y="4754880"/>
+            <a:ext cx="8229600" cy="388620"/>
+          </a:xfrm>
+          <a:prstGeom prst="rect">
+            <a:avLst/>
+          </a:prstGeom>
+          <a:noFill/>
+          <a:ln/>
+        </p:spPr>
+        <p:txBody>
+          <a:bodyPr wrap="square" lIns="0" tIns="0" rIns="0" bIns="0" rtlCol="0" anchor="ctr"/>
+          <a:lstStyle/>
+          <a:p>
+            <a:pPr indent="0" marL="0">
+              <a:buNone/>
+            </a:pPr>
+            <a:r>
+              <a:rPr lang="en-US" sz="900" dirty="0">
+                <a:solidFill>
+                  <a:srgbClr val="CADCFC"/>
+                </a:solidFill>
+                <a:latin typeface="Calibri" pitchFamily="34" charset="0"/>
+                <a:ea typeface="Calibri" pitchFamily="34" charset="-122"/>
+                <a:cs typeface="Calibri" pitchFamily="34" charset="-120"/>
+              </a:rPr>
+              <a:t>出典: Google Cloud Marketplace Partners Documentation (cloud.google.com/marketplace/docs/partners/ai-agents)</a:t>
+            </a:r>
+            <a:endParaRPr lang="en-US" sz="900" dirty="0"/>
+          </a:p>
+        </p:txBody>
+      </p:sp>
+    </p:spTree>
+  </p:cSld>
+  <p:clrMapOvr>
+    <a:masterClrMapping/>
+  </p:clrMapOvr>
+</p:sld>
+</file>
+
+<file path=ppt/slides/slide18.xml><?xml version="1.0" encoding="utf-8"?>
+<p:sld xmlns:a="http://schemas.openxmlformats.org/drawingml/2006/main" xmlns:r="http://schemas.openxmlformats.org/officeDocument/2006/relationships" xmlns:p="http://schemas.openxmlformats.org/presentationml/2006/main">
+  <p:cSld name="Slide 2">
+    <p:bg>
+      <p:bgPr>
+        <a:solidFill>
+          <a:srgbClr val="F0F4F8"/>
+        </a:solidFill>
+      </p:bgPr>
+    </p:bg>
+    <p:spTree>
+      <p:nvGrpSpPr>
+        <p:cNvPr id="1" name=""/>
+        <p:cNvGrpSpPr/>
+        <p:nvPr/>
+      </p:nvGrpSpPr>
+      <p:grpSpPr>
+        <a:xfrm>
+          <a:off x="0" y="0"/>
+          <a:ext cx="0" cy="0"/>
+          <a:chOff x="0" y="0"/>
+          <a:chExt cx="0" cy="0"/>
+        </a:xfrm>
+      </p:grpSpPr>
+      <p:sp>
+        <p:nvSpPr>
+          <p:cNvPr id="2" name="Shape 0"/>
+          <p:cNvSpPr/>
+          <p:nvPr/>
+        </p:nvSpPr>
+        <p:spPr>
+          <a:xfrm>
+            <a:off x="0" y="0"/>
+            <a:ext cx="9144000" cy="54864"/>
+          </a:xfrm>
+          <a:prstGeom prst="rect">
+            <a:avLst/>
+          </a:prstGeom>
+          <a:solidFill>
+            <a:srgbClr val="00A896"/>
+          </a:solidFill>
+          <a:ln/>
+        </p:spPr>
+      </p:sp>
+      <p:sp>
+        <p:nvSpPr>
+          <p:cNvPr id="3" name="Text 1"/>
+          <p:cNvSpPr/>
+          <p:nvPr/>
+        </p:nvSpPr>
+        <p:spPr>
+          <a:xfrm>
+            <a:off x="640080" y="274320"/>
+            <a:ext cx="7315200" cy="640080"/>
+          </a:xfrm>
+          <a:prstGeom prst="rect">
+            <a:avLst/>
+          </a:prstGeom>
+          <a:noFill/>
+          <a:ln/>
+        </p:spPr>
+        <p:txBody>
+          <a:bodyPr wrap="square" lIns="0" tIns="0" rIns="0" bIns="0" rtlCol="0" anchor="ctr"/>
+          <a:lstStyle/>
+          <a:p>
+            <a:pPr indent="0" marL="0">
+              <a:buNone/>
+            </a:pPr>
+            <a:r>
+              <a:rPr lang="en-US" sz="2200" b="1" dirty="0">
+                <a:solidFill>
+                  <a:srgbClr val="1E2761"/>
+                </a:solidFill>
+                <a:latin typeface="Georgia" pitchFamily="34" charset="0"/>
+                <a:ea typeface="Georgia" pitchFamily="34" charset="-122"/>
+                <a:cs typeface="Georgia" pitchFamily="34" charset="-120"/>
+              </a:rPr>
+              <a:t>パートナー公開フロー（Producer Portal）</a:t>
+            </a:r>
+            <a:endParaRPr lang="en-US" sz="2200" dirty="0"/>
+          </a:p>
+        </p:txBody>
+      </p:sp>
+      <p:sp>
+        <p:nvSpPr>
+          <p:cNvPr id="4" name="Shape 2"/>
+          <p:cNvSpPr/>
+          <p:nvPr/>
+        </p:nvSpPr>
+        <p:spPr>
+          <a:xfrm>
+            <a:off x="640080" y="1097280"/>
+            <a:ext cx="4754880" cy="3566160"/>
+          </a:xfrm>
+          <a:prstGeom prst="rect">
+            <a:avLst/>
+          </a:prstGeom>
+          <a:solidFill>
+            <a:srgbClr val="FFFFFF"/>
+          </a:solidFill>
+          <a:ln/>
+          <a:effectLst>
+            <a:outerShdw sx="100000" sy="100000" kx="0" ky="0" algn="bl" rotWithShape="0" blurRad="76200" dist="25400" dir="8100000">
+              <a:srgbClr val="000000">
+                <a:alpha val="12000"/>
+              </a:srgbClr>
+            </a:outerShdw>
+          </a:effectLst>
+        </p:spPr>
+      </p:sp>
+      <p:sp>
+        <p:nvSpPr>
+          <p:cNvPr id="5" name="Text 3"/>
+          <p:cNvSpPr/>
+          <p:nvPr/>
+        </p:nvSpPr>
+        <p:spPr>
+          <a:xfrm>
+            <a:off x="914400" y="1188720"/>
+            <a:ext cx="4206240" cy="3383280"/>
+          </a:xfrm>
+          <a:prstGeom prst="rect">
+            <a:avLst/>
+          </a:prstGeom>
+          <a:noFill/>
+          <a:ln/>
+        </p:spPr>
+        <p:txBody>
+          <a:bodyPr wrap="square" lIns="0" tIns="0" rIns="0" bIns="0" rtlCol="0" anchor="t"/>
+          <a:lstStyle/>
+          <a:p>
+            <a:pPr indent="0" marL="0">
+              <a:buNone/>
+            </a:pPr>
+            <a:r>
+              <a:rPr lang="en-US" sz="1300" b="1" dirty="0">
+                <a:solidFill>
+                  <a:srgbClr val="065A82"/>
+                </a:solidFill>
+              </a:rPr>
+              <a:t>AIエージェントをMarketplaceに公開するまでの7フェーズ</a:t>
+            </a:r>
+            <a:endParaRPr lang="en-US" sz="1300" dirty="0"/>
+          </a:p>
+          <a:p>
+            <a:pPr indent="0" marL="0">
+              <a:buNone/>
+            </a:pPr>
+            <a:endParaRPr lang="en-US" sz="1300" dirty="0"/>
+          </a:p>
+          <a:p>
+            <a:pPr indent="0" marL="0">
+              <a:buNone/>
+            </a:pPr>
+            <a:r>
+              <a:rPr lang="en-US" sz="1200" b="1" dirty="0">
+                <a:solidFill>
+                  <a:srgbClr val="065A82"/>
+                </a:solidFill>
+              </a:rPr>
+              <a:t>Phase 1-2: 準備・登録</a:t>
+            </a:r>
+            <a:endParaRPr lang="en-US" sz="1300" dirty="0"/>
+          </a:p>
+          <a:p>
+            <a:pPr indent="0" marL="0">
+              <a:buNone/>
+            </a:pPr>
+            <a:r>
+              <a:rPr lang="en-US" sz="1300" dirty="0">
+                <a:solidFill>
+                  <a:srgbClr val="1E293B"/>
+                </a:solidFill>
+              </a:rPr>
+              <a:t>ベンダー登録 → Producer Portalアクセス取得 → AIエージェント（サービス）としてプロダクト作成</a:t>
+            </a:r>
+            <a:endParaRPr lang="en-US" sz="1300" dirty="0"/>
+          </a:p>
+          <a:p>
+            <a:pPr indent="0" marL="0">
+              <a:buNone/>
+            </a:pPr>
+            <a:endParaRPr lang="en-US" sz="1300" dirty="0"/>
+          </a:p>
+          <a:p>
+            <a:pPr indent="0" marL="0">
+              <a:buNone/>
+            </a:pPr>
+            <a:r>
+              <a:rPr lang="en-US" sz="1200" b="1" dirty="0">
+                <a:solidFill>
+                  <a:srgbClr val="065A82"/>
+                </a:solidFill>
+              </a:rPr>
+              <a:t>Phase 3-4: 詳細・料金</a:t>
+            </a:r>
+            <a:endParaRPr lang="en-US" sz="1300" dirty="0"/>
+          </a:p>
+          <a:p>
+            <a:pPr indent="0" marL="0">
+              <a:buNone/>
+            </a:pPr>
+            <a:r>
+              <a:rPr lang="en-US" sz="1300" dirty="0">
+                <a:solidFill>
+                  <a:srgbClr val="1E293B"/>
+                </a:solidFill>
+              </a:rPr>
+              <a:t>プロダクト詳細を入力 → 料金モデル選択（無料/サブスク/従量制/併用） → 審査（最大4営業日）</a:t>
+            </a:r>
+            <a:endParaRPr lang="en-US" sz="1300" dirty="0"/>
+          </a:p>
+          <a:p>
+            <a:pPr indent="0" marL="0">
+              <a:buNone/>
+            </a:pPr>
+            <a:endParaRPr lang="en-US" sz="1300" dirty="0"/>
+          </a:p>
+          <a:p>
+            <a:pPr indent="0" marL="0">
+              <a:buNone/>
+            </a:pPr>
+            <a:r>
+              <a:rPr lang="en-US" sz="1200" b="1" dirty="0">
+                <a:solidFill>
+                  <a:srgbClr val="065A82"/>
+                </a:solidFill>
+              </a:rPr>
+              <a:t>Phase 5-6: Agent Card・技術統合</a:t>
+            </a:r>
+            <a:endParaRPr lang="en-US" sz="1300" dirty="0"/>
+          </a:p>
+          <a:p>
+            <a:pPr indent="0" marL="0">
+              <a:buNone/>
+            </a:pPr>
+            <a:r>
+              <a:rPr lang="en-US" sz="1300" dirty="0">
+                <a:solidFill>
+                  <a:srgbClr val="1E293B"/>
+                </a:solidFill>
+              </a:rPr>
+              <a:t>Agent CardをGCSに登録 → Pub/Sub（契約イベント通知）・Procurement API（課金連携）統合</a:t>
+            </a:r>
+            <a:endParaRPr lang="en-US" sz="1300" dirty="0"/>
+          </a:p>
+          <a:p>
+            <a:pPr indent="0" marL="0">
+              <a:buNone/>
+            </a:pPr>
+            <a:endParaRPr lang="en-US" sz="1300" dirty="0"/>
+          </a:p>
+          <a:p>
+            <a:pPr indent="0" marL="0">
+              <a:buNone/>
+            </a:pPr>
+            <a:r>
+              <a:rPr lang="en-US" sz="1200" b="1" dirty="0">
+                <a:solidFill>
+                  <a:srgbClr val="065A82"/>
+                </a:solidFill>
+              </a:rPr>
+              <a:t>Phase 7: 公開</a:t>
+            </a:r>
+            <a:endParaRPr lang="en-US" sz="1300" dirty="0"/>
+          </a:p>
+          <a:p>
+            <a:pPr indent="0" marL="0">
+              <a:buNone/>
+            </a:pPr>
+            <a:r>
+              <a:rPr lang="en-US" sz="1300" dirty="0">
+                <a:solidFill>
+                  <a:srgbClr val="1E293B"/>
+                </a:solidFill>
+              </a:rPr>
+              <a:t>審査送付 → 承認後に公開（最大2日） → Marketplaceで一般公開</a:t>
+            </a:r>
+            <a:endParaRPr lang="en-US" sz="1300" dirty="0"/>
+          </a:p>
+        </p:txBody>
+      </p:sp>
+      <p:sp>
+        <p:nvSpPr>
+          <p:cNvPr id="6" name="Shape 4"/>
+          <p:cNvSpPr/>
+          <p:nvPr/>
+        </p:nvSpPr>
+        <p:spPr>
+          <a:xfrm>
+            <a:off x="5760720" y="1188720"/>
+            <a:ext cx="2926080" cy="960120"/>
+          </a:xfrm>
+          <a:prstGeom prst="rect">
+            <a:avLst/>
+          </a:prstGeom>
+          <a:solidFill>
+            <a:srgbClr val="FFFFFF"/>
+          </a:solidFill>
+          <a:ln/>
+          <a:effectLst>
+            <a:outerShdw sx="100000" sy="100000" kx="0" ky="0" algn="bl" rotWithShape="0" blurRad="76200" dist="25400" dir="8100000">
+              <a:srgbClr val="000000">
+                <a:alpha val="12000"/>
+              </a:srgbClr>
+            </a:outerShdw>
+          </a:effectLst>
+        </p:spPr>
+      </p:sp>
+      <p:pic>
+        <p:nvPicPr>
+          <p:cNvPr id="7" name="Image 0" descr="preencoded.png"/>
+          <p:cNvPicPr>
+            <a:picLocks noChangeAspect="1"/>
+          </p:cNvPicPr>
+          <p:nvPr/>
+        </p:nvPicPr>
+        <p:blipFill>
+          <a:blip r:embed="rId1"/>
+          <a:stretch>
+            <a:fillRect/>
+          </a:stretch>
+        </p:blipFill>
+        <p:spPr>
+          <a:xfrm>
+            <a:off x="5989320" y="1371600"/>
+            <a:ext cx="502920" cy="502920"/>
+          </a:xfrm>
+          <a:prstGeom prst="rect">
+            <a:avLst/>
+          </a:prstGeom>
+        </p:spPr>
+      </p:pic>
+      <p:sp>
+        <p:nvSpPr>
+          <p:cNvPr id="8" name="Text 5"/>
+          <p:cNvSpPr/>
+          <p:nvPr/>
+        </p:nvSpPr>
+        <p:spPr>
+          <a:xfrm>
+            <a:off x="6675120" y="1188720"/>
+            <a:ext cx="1828800" cy="960120"/>
+          </a:xfrm>
+          <a:prstGeom prst="rect">
+            <a:avLst/>
+          </a:prstGeom>
+          <a:noFill/>
+          <a:ln/>
+        </p:spPr>
+        <p:txBody>
+          <a:bodyPr wrap="square" lIns="0" tIns="0" rIns="0" bIns="0" rtlCol="0" anchor="ctr"/>
+          <a:lstStyle/>
+          <a:p>
+            <a:pPr indent="0" marL="0">
+              <a:buNone/>
+            </a:pPr>
+            <a:r>
+              <a:rPr lang="en-US" sz="1300" b="1" dirty="0">
+                <a:solidFill>
+                  <a:srgbClr val="1E293B"/>
+                </a:solidFill>
+                <a:latin typeface="Calibri" pitchFamily="34" charset="0"/>
+                <a:ea typeface="Calibri" pitchFamily="34" charset="-122"/>
+                <a:cs typeface="Calibri" pitchFamily="34" charset="-120"/>
+              </a:rPr>
+              <a:t>Producer Portal</a:t>
+            </a:r>
+            <a:endParaRPr lang="en-US" sz="1300" dirty="0"/>
+          </a:p>
+        </p:txBody>
+      </p:sp>
+      <p:sp>
+        <p:nvSpPr>
+          <p:cNvPr id="9" name="Shape 6"/>
+          <p:cNvSpPr/>
+          <p:nvPr/>
+        </p:nvSpPr>
+        <p:spPr>
+          <a:xfrm>
+            <a:off x="5760720" y="2331720"/>
+            <a:ext cx="2926080" cy="960120"/>
+          </a:xfrm>
+          <a:prstGeom prst="rect">
+            <a:avLst/>
+          </a:prstGeom>
+          <a:solidFill>
+            <a:srgbClr val="FFFFFF"/>
+          </a:solidFill>
+          <a:ln/>
+          <a:effectLst>
+            <a:outerShdw sx="100000" sy="100000" kx="0" ky="0" algn="bl" rotWithShape="0" blurRad="76200" dist="25400" dir="8100000">
+              <a:srgbClr val="000000">
+                <a:alpha val="12000"/>
+              </a:srgbClr>
+            </a:outerShdw>
+          </a:effectLst>
+        </p:spPr>
+      </p:sp>
+      <p:pic>
+        <p:nvPicPr>
+          <p:cNvPr id="10" name="Image 1" descr="preencoded.png"/>
+          <p:cNvPicPr>
+            <a:picLocks noChangeAspect="1"/>
+          </p:cNvPicPr>
+          <p:nvPr/>
+        </p:nvPicPr>
+        <p:blipFill>
+          <a:blip r:embed="rId2"/>
+          <a:stretch>
+            <a:fillRect/>
+          </a:stretch>
+        </p:blipFill>
+        <p:spPr>
+          <a:xfrm>
+            <a:off x="5989320" y="2514600"/>
+            <a:ext cx="502920" cy="502920"/>
+          </a:xfrm>
+          <a:prstGeom prst="rect">
+            <a:avLst/>
+          </a:prstGeom>
+        </p:spPr>
+      </p:pic>
+      <p:sp>
+        <p:nvSpPr>
+          <p:cNvPr id="11" name="Text 7"/>
+          <p:cNvSpPr/>
+          <p:nvPr/>
+        </p:nvSpPr>
+        <p:spPr>
+          <a:xfrm>
+            <a:off x="6675120" y="2331720"/>
+            <a:ext cx="1828800" cy="960120"/>
+          </a:xfrm>
+          <a:prstGeom prst="rect">
+            <a:avLst/>
+          </a:prstGeom>
+          <a:noFill/>
+          <a:ln/>
+        </p:spPr>
+        <p:txBody>
+          <a:bodyPr wrap="square" lIns="0" tIns="0" rIns="0" bIns="0" rtlCol="0" anchor="ctr"/>
+          <a:lstStyle/>
+          <a:p>
+            <a:pPr indent="0" marL="0">
+              <a:buNone/>
+            </a:pPr>
+            <a:r>
+              <a:rPr lang="en-US" sz="1300" b="1" dirty="0">
+                <a:solidFill>
+                  <a:srgbClr val="1E293B"/>
+                </a:solidFill>
+                <a:latin typeface="Calibri" pitchFamily="34" charset="0"/>
+                <a:ea typeface="Calibri" pitchFamily="34" charset="-122"/>
+                <a:cs typeface="Calibri" pitchFamily="34" charset="-120"/>
+              </a:rPr>
+              <a:t>4つの料金モデル</a:t>
+            </a:r>
+            <a:endParaRPr lang="en-US" sz="1300" dirty="0"/>
+          </a:p>
+        </p:txBody>
+      </p:sp>
+      <p:sp>
+        <p:nvSpPr>
+          <p:cNvPr id="12" name="Shape 8"/>
+          <p:cNvSpPr/>
+          <p:nvPr/>
+        </p:nvSpPr>
+        <p:spPr>
+          <a:xfrm>
+            <a:off x="5760720" y="3474720"/>
+            <a:ext cx="2926080" cy="960120"/>
+          </a:xfrm>
+          <a:prstGeom prst="rect">
+            <a:avLst/>
+          </a:prstGeom>
+          <a:solidFill>
+            <a:srgbClr val="FFFFFF"/>
+          </a:solidFill>
+          <a:ln/>
+          <a:effectLst>
+            <a:outerShdw sx="100000" sy="100000" kx="0" ky="0" algn="bl" rotWithShape="0" blurRad="76200" dist="25400" dir="8100000">
+              <a:srgbClr val="000000">
+                <a:alpha val="12000"/>
+              </a:srgbClr>
+            </a:outerShdw>
+          </a:effectLst>
+        </p:spPr>
+      </p:sp>
+      <p:pic>
+        <p:nvPicPr>
+          <p:cNvPr id="13" name="Image 2" descr="preencoded.png"/>
+          <p:cNvPicPr>
+            <a:picLocks noChangeAspect="1"/>
+          </p:cNvPicPr>
+          <p:nvPr/>
+        </p:nvPicPr>
+        <p:blipFill>
+          <a:blip r:embed="rId3"/>
+          <a:stretch>
+            <a:fillRect/>
+          </a:stretch>
+        </p:blipFill>
+        <p:spPr>
+          <a:xfrm>
+            <a:off x="5989320" y="3657600"/>
+            <a:ext cx="502920" cy="502920"/>
+          </a:xfrm>
+          <a:prstGeom prst="rect">
+            <a:avLst/>
+          </a:prstGeom>
+        </p:spPr>
+      </p:pic>
+      <p:sp>
+        <p:nvSpPr>
+          <p:cNvPr id="14" name="Text 9"/>
+          <p:cNvSpPr/>
+          <p:nvPr/>
+        </p:nvSpPr>
+        <p:spPr>
+          <a:xfrm>
+            <a:off x="6675120" y="3474720"/>
+            <a:ext cx="1828800" cy="960120"/>
+          </a:xfrm>
+          <a:prstGeom prst="rect">
+            <a:avLst/>
+          </a:prstGeom>
+          <a:noFill/>
+          <a:ln/>
+        </p:spPr>
+        <p:txBody>
+          <a:bodyPr wrap="square" lIns="0" tIns="0" rIns="0" bIns="0" rtlCol="0" anchor="ctr"/>
+          <a:lstStyle/>
+          <a:p>
+            <a:pPr indent="0" marL="0">
+              <a:buNone/>
+            </a:pPr>
+            <a:r>
+              <a:rPr lang="en-US" sz="1300" b="1" dirty="0">
+                <a:solidFill>
+                  <a:srgbClr val="1E293B"/>
+                </a:solidFill>
+                <a:latin typeface="Calibri" pitchFamily="34" charset="0"/>
+                <a:ea typeface="Calibri" pitchFamily="34" charset="-122"/>
+                <a:cs typeface="Calibri" pitchFamily="34" charset="-120"/>
+              </a:rPr>
+              <a:t>Agent Card (JSON)</a:t>
+            </a:r>
+            <a:endParaRPr lang="en-US" sz="1300" dirty="0"/>
+          </a:p>
+        </p:txBody>
+      </p:sp>
+      <p:sp>
+        <p:nvSpPr>
+          <p:cNvPr id="15" name="Shape 10"/>
+          <p:cNvSpPr/>
+          <p:nvPr/>
+        </p:nvSpPr>
+        <p:spPr>
+          <a:xfrm>
+            <a:off x="0" y="4754880"/>
+            <a:ext cx="9144000" cy="388620"/>
+          </a:xfrm>
+          <a:prstGeom prst="rect">
+            <a:avLst/>
+          </a:prstGeom>
+          <a:solidFill>
+            <a:srgbClr val="1E2761"/>
+          </a:solidFill>
+          <a:ln/>
+        </p:spPr>
+      </p:sp>
+      <p:sp>
+        <p:nvSpPr>
+          <p:cNvPr id="16" name="Text 11"/>
+          <p:cNvSpPr/>
+          <p:nvPr/>
+        </p:nvSpPr>
+        <p:spPr>
+          <a:xfrm>
+            <a:off x="457200" y="4754880"/>
+            <a:ext cx="8229600" cy="388620"/>
+          </a:xfrm>
+          <a:prstGeom prst="rect">
+            <a:avLst/>
+          </a:prstGeom>
+          <a:noFill/>
+          <a:ln/>
+        </p:spPr>
+        <p:txBody>
+          <a:bodyPr wrap="square" lIns="0" tIns="0" rIns="0" bIns="0" rtlCol="0" anchor="ctr"/>
+          <a:lstStyle/>
+          <a:p>
+            <a:pPr indent="0" marL="0">
+              <a:buNone/>
+            </a:pPr>
+            <a:r>
+              <a:rPr lang="en-US" sz="900" dirty="0">
+                <a:solidFill>
+                  <a:srgbClr val="CADCFC"/>
+                </a:solidFill>
+                <a:latin typeface="Calibri" pitchFamily="34" charset="0"/>
+                <a:ea typeface="Calibri" pitchFamily="34" charset="-122"/>
+                <a:cs typeface="Calibri" pitchFamily="34" charset="-120"/>
+              </a:rPr>
+              <a:t>出典: docs.cloud.google.com/marketplace/docs/partners/ai-agents</a:t>
+            </a:r>
+            <a:endParaRPr lang="en-US" sz="900" dirty="0"/>
+          </a:p>
+        </p:txBody>
+      </p:sp>
+    </p:spTree>
+  </p:cSld>
+  <p:clrMapOvr>
+    <a:masterClrMapping/>
+  </p:clrMapOvr>
+</p:sld>
+</file>
+
+<file path=ppt/slides/slide19.xml><?xml version="1.0" encoding="utf-8"?>
+<p:sld xmlns:a="http://schemas.openxmlformats.org/drawingml/2006/main" xmlns:r="http://schemas.openxmlformats.org/officeDocument/2006/relationships" xmlns:p="http://schemas.openxmlformats.org/presentationml/2006/main">
+  <p:cSld name="Slide 2">
+    <p:bg>
+      <p:bgPr>
+        <a:solidFill>
+          <a:srgbClr val="F0F4F8"/>
+        </a:solidFill>
+      </p:bgPr>
+    </p:bg>
+    <p:spTree>
+      <p:nvGrpSpPr>
+        <p:cNvPr id="1" name=""/>
+        <p:cNvGrpSpPr/>
+        <p:nvPr/>
+      </p:nvGrpSpPr>
+      <p:grpSpPr>
+        <a:xfrm>
+          <a:off x="0" y="0"/>
+          <a:ext cx="0" cy="0"/>
+          <a:chOff x="0" y="0"/>
+          <a:chExt cx="0" cy="0"/>
+        </a:xfrm>
+      </p:grpSpPr>
+      <p:sp>
+        <p:nvSpPr>
+          <p:cNvPr id="2" name="Shape 0"/>
+          <p:cNvSpPr/>
+          <p:nvPr/>
+        </p:nvSpPr>
+        <p:spPr>
+          <a:xfrm>
+            <a:off x="0" y="0"/>
+            <a:ext cx="9144000" cy="54864"/>
+          </a:xfrm>
+          <a:prstGeom prst="rect">
+            <a:avLst/>
+          </a:prstGeom>
+          <a:solidFill>
+            <a:srgbClr val="00A896"/>
+          </a:solidFill>
+          <a:ln/>
+        </p:spPr>
+      </p:sp>
+      <p:sp>
+        <p:nvSpPr>
+          <p:cNvPr id="3" name="Text 1"/>
+          <p:cNvSpPr/>
+          <p:nvPr/>
+        </p:nvSpPr>
+        <p:spPr>
+          <a:xfrm>
+            <a:off x="640080" y="274320"/>
+            <a:ext cx="7315200" cy="640080"/>
+          </a:xfrm>
+          <a:prstGeom prst="rect">
+            <a:avLst/>
+          </a:prstGeom>
+          <a:noFill/>
+          <a:ln/>
+        </p:spPr>
+        <p:txBody>
+          <a:bodyPr wrap="square" lIns="0" tIns="0" rIns="0" bIns="0" rtlCol="0" anchor="ctr"/>
+          <a:lstStyle/>
+          <a:p>
+            <a:pPr indent="0" marL="0">
+              <a:buNone/>
+            </a:pPr>
+            <a:r>
+              <a:rPr lang="en-US" sz="3000" b="1" dirty="0">
+                <a:solidFill>
+                  <a:srgbClr val="1E2761"/>
+                </a:solidFill>
+                <a:latin typeface="Georgia" pitchFamily="34" charset="0"/>
+                <a:ea typeface="Georgia" pitchFamily="34" charset="-122"/>
+                <a:cs typeface="Georgia" pitchFamily="34" charset="-120"/>
+              </a:rPr>
+              <a:t>顧客のエージェント利用フロー</a:t>
+            </a:r>
+            <a:endParaRPr lang="en-US" sz="3000" dirty="0"/>
+          </a:p>
+        </p:txBody>
+      </p:sp>
+      <p:sp>
+        <p:nvSpPr>
+          <p:cNvPr id="4" name="Shape 2"/>
+          <p:cNvSpPr/>
+          <p:nvPr/>
+        </p:nvSpPr>
+        <p:spPr>
+          <a:xfrm>
+            <a:off x="640080" y="1188720"/>
+            <a:ext cx="4754880" cy="3291840"/>
+          </a:xfrm>
+          <a:prstGeom prst="rect">
+            <a:avLst/>
+          </a:prstGeom>
+          <a:solidFill>
+            <a:srgbClr val="FFFFFF"/>
+          </a:solidFill>
+          <a:ln/>
+          <a:effectLst>
+            <a:outerShdw sx="100000" sy="100000" kx="0" ky="0" algn="bl" rotWithShape="0" blurRad="76200" dist="25400" dir="8100000">
+              <a:srgbClr val="000000">
+                <a:alpha val="12000"/>
+              </a:srgbClr>
+            </a:outerShdw>
+          </a:effectLst>
+        </p:spPr>
+      </p:sp>
+      <p:sp>
+        <p:nvSpPr>
+          <p:cNvPr id="5" name="Text 3"/>
+          <p:cNvSpPr/>
+          <p:nvPr/>
+        </p:nvSpPr>
+        <p:spPr>
+          <a:xfrm>
+            <a:off x="914400" y="1371600"/>
+            <a:ext cx="4206240" cy="2926080"/>
+          </a:xfrm>
+          <a:prstGeom prst="rect">
+            <a:avLst/>
+          </a:prstGeom>
+          <a:noFill/>
+          <a:ln/>
+        </p:spPr>
+        <p:txBody>
+          <a:bodyPr wrap="square" lIns="0" tIns="0" rIns="0" bIns="0" rtlCol="0" anchor="t"/>
+          <a:lstStyle/>
+          <a:p>
+            <a:pPr indent="0" marL="0">
+              <a:buNone/>
+            </a:pPr>
+            <a:r>
+              <a:rPr lang="en-US" sz="1600" b="1" dirty="0">
+                <a:solidFill>
+                  <a:srgbClr val="065A82"/>
+                </a:solidFill>
+              </a:rPr>
+              <a:t>Gemini Enterpriseへの追加から利用開始までの流れ</a:t>
+            </a:r>
+            <a:endParaRPr lang="en-US" sz="1600" dirty="0"/>
+          </a:p>
+          <a:p>
+            <a:pPr indent="0" marL="0">
+              <a:buNone/>
+            </a:pPr>
+            <a:endParaRPr lang="en-US" sz="1600" dirty="0"/>
+          </a:p>
+          <a:p>
+            <a:pPr indent="0" marL="0">
+              <a:buNone/>
+            </a:pPr>
+            <a:r>
+              <a:rPr lang="en-US" sz="1400" b="1" dirty="0">
+                <a:solidFill>
+                  <a:srgbClr val="065A82"/>
+                </a:solidFill>
+              </a:rPr>
+              <a:t>Step 1: 検索・発見</a:t>
+            </a:r>
+            <a:endParaRPr lang="en-US" sz="1600" dirty="0"/>
+          </a:p>
+          <a:p>
+            <a:pPr indent="0" marL="0">
+              <a:buNone/>
+            </a:pPr>
+            <a:r>
+              <a:rPr lang="en-US" sz="1300" dirty="0">
+                <a:solidFill>
+                  <a:srgbClr val="1E293B"/>
+                </a:solidFill>
+              </a:rPr>
+              <a:t>Cloud Marketplaceの「AIエージェント」カテゴリからエージェントを検索。Agent Cardで能力を確認</a:t>
+            </a:r>
+            <a:endParaRPr lang="en-US" sz="1600" dirty="0"/>
+          </a:p>
+          <a:p>
+            <a:pPr indent="0" marL="0">
+              <a:buNone/>
+            </a:pPr>
+            <a:endParaRPr lang="en-US" sz="1600" dirty="0"/>
+          </a:p>
+          <a:p>
+            <a:pPr indent="0" marL="0">
+              <a:buNone/>
+            </a:pPr>
+            <a:r>
+              <a:rPr lang="en-US" sz="1400" b="1" dirty="0">
+                <a:solidFill>
+                  <a:srgbClr val="065A82"/>
+                </a:solidFill>
+              </a:rPr>
+              <a:t>Step 2: 追加（8ステップUI）</a:t>
+            </a:r>
+            <a:endParaRPr lang="en-US" sz="1600" dirty="0"/>
+          </a:p>
+          <a:p>
+            <a:pPr indent="0" marL="0">
+              <a:buNone/>
+            </a:pPr>
+            <a:r>
+              <a:rPr lang="en-US" sz="1300" dirty="0">
+                <a:solidFill>
+                  <a:srgbClr val="1E293B"/>
+                </a:solidFill>
+              </a:rPr>
+              <a:t>Cloud Console内で「Agents via Marketplace」→ 検索・選択 → ベンダー側の認証情報（APIキー等）を入力 → 完了</a:t>
+            </a:r>
+            <a:endParaRPr lang="en-US" sz="1600" dirty="0"/>
+          </a:p>
+          <a:p>
+            <a:pPr indent="0" marL="0">
+              <a:buNone/>
+            </a:pPr>
+            <a:endParaRPr lang="en-US" sz="1600" dirty="0"/>
+          </a:p>
+          <a:p>
+            <a:pPr indent="0" marL="0">
+              <a:buNone/>
+            </a:pPr>
+            <a:r>
+              <a:rPr lang="en-US" sz="1400" b="1" dirty="0">
+                <a:solidFill>
+                  <a:srgbClr val="065A82"/>
+                </a:solidFill>
+              </a:rPr>
+              <a:t>Step 3: 利用開始</a:t>
+            </a:r>
+            <a:endParaRPr lang="en-US" sz="1600" dirty="0"/>
+          </a:p>
+          <a:p>
+            <a:pPr indent="0" marL="0">
+              <a:buNone/>
+            </a:pPr>
+            <a:r>
+              <a:rPr lang="en-US" sz="1300" dirty="0">
+                <a:solidFill>
+                  <a:srgbClr val="1E293B"/>
+                </a:solidFill>
+              </a:rPr>
+              <a:t>Gemini Enterprise上でエージェントと対話。A2Aプロトコルで他エージェントとも連携</a:t>
+            </a:r>
+            <a:endParaRPr lang="en-US" sz="1600" dirty="0"/>
+          </a:p>
+          <a:p>
+            <a:pPr indent="0" marL="0">
+              <a:buNone/>
+            </a:pPr>
+            <a:endParaRPr lang="en-US" sz="1600" dirty="0"/>
+          </a:p>
+          <a:p>
+            <a:pPr indent="0" marL="0">
+              <a:buNone/>
+            </a:pPr>
+            <a:r>
+              <a:rPr lang="en-US" sz="1400" b="1" dirty="0">
+                <a:solidFill>
+                  <a:srgbClr val="065A82"/>
+                </a:solidFill>
+              </a:rPr>
+              <a:t>課金</a:t>
+            </a:r>
+            <a:endParaRPr lang="en-US" sz="1600" dirty="0"/>
+          </a:p>
+          <a:p>
+            <a:pPr indent="0" marL="0">
+              <a:buNone/>
+            </a:pPr>
+            <a:r>
+              <a:rPr lang="en-US" sz="1300" dirty="0">
+                <a:solidFill>
+                  <a:srgbClr val="1E293B"/>
+                </a:solidFill>
+              </a:rPr>
+              <a:t>Googleから一元請求。パートナー料金（サブスク/従量制）+ Google Cloudリソース料金</a:t>
+            </a:r>
+            <a:endParaRPr lang="en-US" sz="1600" dirty="0"/>
+          </a:p>
+        </p:txBody>
+      </p:sp>
+      <p:sp>
+        <p:nvSpPr>
+          <p:cNvPr id="6" name="Shape 4"/>
+          <p:cNvSpPr/>
+          <p:nvPr/>
+        </p:nvSpPr>
+        <p:spPr>
+          <a:xfrm>
+            <a:off x="5760720" y="1188720"/>
+            <a:ext cx="2926080" cy="960120"/>
+          </a:xfrm>
+          <a:prstGeom prst="rect">
+            <a:avLst/>
+          </a:prstGeom>
+          <a:solidFill>
+            <a:srgbClr val="FFFFFF"/>
+          </a:solidFill>
+          <a:ln/>
+          <a:effectLst>
+            <a:outerShdw sx="100000" sy="100000" kx="0" ky="0" algn="bl" rotWithShape="0" blurRad="76200" dist="25400" dir="8100000">
+              <a:srgbClr val="000000">
+                <a:alpha val="12000"/>
+              </a:srgbClr>
+            </a:outerShdw>
+          </a:effectLst>
+        </p:spPr>
+      </p:sp>
+      <p:pic>
+        <p:nvPicPr>
+          <p:cNvPr id="7" name="Image 0" descr="preencoded.png"/>
+          <p:cNvPicPr>
+            <a:picLocks noChangeAspect="1"/>
+          </p:cNvPicPr>
+          <p:nvPr/>
+        </p:nvPicPr>
+        <p:blipFill>
+          <a:blip r:embed="rId1"/>
+          <a:stretch>
+            <a:fillRect/>
+          </a:stretch>
+        </p:blipFill>
+        <p:spPr>
+          <a:xfrm>
+            <a:off x="5989320" y="1371600"/>
+            <a:ext cx="502920" cy="502920"/>
+          </a:xfrm>
+          <a:prstGeom prst="rect">
+            <a:avLst/>
+          </a:prstGeom>
+        </p:spPr>
+      </p:pic>
+      <p:sp>
+        <p:nvSpPr>
+          <p:cNvPr id="8" name="Text 5"/>
+          <p:cNvSpPr/>
+          <p:nvPr/>
+        </p:nvSpPr>
+        <p:spPr>
+          <a:xfrm>
+            <a:off x="6675120" y="1188720"/>
+            <a:ext cx="1828800" cy="960120"/>
+          </a:xfrm>
+          <a:prstGeom prst="rect">
+            <a:avLst/>
+          </a:prstGeom>
+          <a:noFill/>
+          <a:ln/>
+        </p:spPr>
+        <p:txBody>
+          <a:bodyPr wrap="square" lIns="0" tIns="0" rIns="0" bIns="0" rtlCol="0" anchor="ctr"/>
+          <a:lstStyle/>
+          <a:p>
+            <a:pPr indent="0" marL="0">
+              <a:buNone/>
+            </a:pPr>
+            <a:r>
+              <a:rPr lang="en-US" sz="1300" b="1" dirty="0">
+                <a:solidFill>
+                  <a:srgbClr val="1E293B"/>
+                </a:solidFill>
+                <a:latin typeface="Calibri" pitchFamily="34" charset="0"/>
+                <a:ea typeface="Calibri" pitchFamily="34" charset="-122"/>
+                <a:cs typeface="Calibri" pitchFamily="34" charset="-120"/>
+              </a:rPr>
+              <a:t>Cloud Console UI</a:t>
+            </a:r>
+            <a:endParaRPr lang="en-US" sz="1300" dirty="0"/>
+          </a:p>
+        </p:txBody>
+      </p:sp>
+      <p:sp>
+        <p:nvSpPr>
+          <p:cNvPr id="9" name="Shape 6"/>
+          <p:cNvSpPr/>
+          <p:nvPr/>
+        </p:nvSpPr>
+        <p:spPr>
+          <a:xfrm>
+            <a:off x="5760720" y="2331720"/>
+            <a:ext cx="2926080" cy="960120"/>
+          </a:xfrm>
+          <a:prstGeom prst="rect">
+            <a:avLst/>
+          </a:prstGeom>
+          <a:solidFill>
+            <a:srgbClr val="FFFFFF"/>
+          </a:solidFill>
+          <a:ln/>
+          <a:effectLst>
+            <a:outerShdw sx="100000" sy="100000" kx="0" ky="0" algn="bl" rotWithShape="0" blurRad="76200" dist="25400" dir="8100000">
+              <a:srgbClr val="000000">
+                <a:alpha val="12000"/>
+              </a:srgbClr>
+            </a:outerShdw>
+          </a:effectLst>
+        </p:spPr>
+      </p:sp>
+      <p:pic>
+        <p:nvPicPr>
+          <p:cNvPr id="10" name="Image 1" descr="preencoded.png"/>
+          <p:cNvPicPr>
+            <a:picLocks noChangeAspect="1"/>
+          </p:cNvPicPr>
+          <p:nvPr/>
+        </p:nvPicPr>
+        <p:blipFill>
+          <a:blip r:embed="rId2"/>
+          <a:stretch>
+            <a:fillRect/>
+          </a:stretch>
+        </p:blipFill>
+        <p:spPr>
+          <a:xfrm>
+            <a:off x="5989320" y="2514600"/>
+            <a:ext cx="502920" cy="502920"/>
+          </a:xfrm>
+          <a:prstGeom prst="rect">
+            <a:avLst/>
+          </a:prstGeom>
+        </p:spPr>
+      </p:pic>
+      <p:sp>
+        <p:nvSpPr>
+          <p:cNvPr id="11" name="Text 7"/>
+          <p:cNvSpPr/>
+          <p:nvPr/>
+        </p:nvSpPr>
+        <p:spPr>
+          <a:xfrm>
+            <a:off x="6675120" y="2331720"/>
+            <a:ext cx="1828800" cy="960120"/>
+          </a:xfrm>
+          <a:prstGeom prst="rect">
+            <a:avLst/>
+          </a:prstGeom>
+          <a:noFill/>
+          <a:ln/>
+        </p:spPr>
+        <p:txBody>
+          <a:bodyPr wrap="square" lIns="0" tIns="0" rIns="0" bIns="0" rtlCol="0" anchor="ctr"/>
+          <a:lstStyle/>
+          <a:p>
+            <a:pPr indent="0" marL="0">
+              <a:buNone/>
+            </a:pPr>
+            <a:r>
+              <a:rPr lang="en-US" sz="1300" b="1" dirty="0">
+                <a:solidFill>
+                  <a:srgbClr val="1E293B"/>
+                </a:solidFill>
+                <a:latin typeface="Calibri" pitchFamily="34" charset="0"/>
+                <a:ea typeface="Calibri" pitchFamily="34" charset="-122"/>
+                <a:cs typeface="Calibri" pitchFamily="34" charset="-120"/>
+              </a:rPr>
+              <a:t>A2Aで相互連携</a:t>
+            </a:r>
+            <a:endParaRPr lang="en-US" sz="1300" dirty="0"/>
+          </a:p>
+        </p:txBody>
+      </p:sp>
+      <p:sp>
+        <p:nvSpPr>
+          <p:cNvPr id="12" name="Shape 8"/>
+          <p:cNvSpPr/>
+          <p:nvPr/>
+        </p:nvSpPr>
+        <p:spPr>
+          <a:xfrm>
+            <a:off x="5760720" y="3474720"/>
+            <a:ext cx="2926080" cy="960120"/>
+          </a:xfrm>
+          <a:prstGeom prst="rect">
+            <a:avLst/>
+          </a:prstGeom>
+          <a:solidFill>
+            <a:srgbClr val="FFFFFF"/>
+          </a:solidFill>
+          <a:ln/>
+          <a:effectLst>
+            <a:outerShdw sx="100000" sy="100000" kx="0" ky="0" algn="bl" rotWithShape="0" blurRad="76200" dist="25400" dir="8100000">
+              <a:srgbClr val="000000">
+                <a:alpha val="12000"/>
+              </a:srgbClr>
+            </a:outerShdw>
+          </a:effectLst>
+        </p:spPr>
+      </p:sp>
+      <p:pic>
+        <p:nvPicPr>
+          <p:cNvPr id="13" name="Image 2" descr="preencoded.png"/>
+          <p:cNvPicPr>
+            <a:picLocks noChangeAspect="1"/>
+          </p:cNvPicPr>
+          <p:nvPr/>
+        </p:nvPicPr>
+        <p:blipFill>
+          <a:blip r:embed="rId3"/>
+          <a:stretch>
+            <a:fillRect/>
+          </a:stretch>
+        </p:blipFill>
+        <p:spPr>
+          <a:xfrm>
+            <a:off x="5989320" y="3657600"/>
+            <a:ext cx="502920" cy="502920"/>
+          </a:xfrm>
+          <a:prstGeom prst="rect">
+            <a:avLst/>
+          </a:prstGeom>
+        </p:spPr>
+      </p:pic>
+      <p:sp>
+        <p:nvSpPr>
+          <p:cNvPr id="14" name="Text 9"/>
+          <p:cNvSpPr/>
+          <p:nvPr/>
+        </p:nvSpPr>
+        <p:spPr>
+          <a:xfrm>
+            <a:off x="6675120" y="3474720"/>
+            <a:ext cx="1828800" cy="960120"/>
+          </a:xfrm>
+          <a:prstGeom prst="rect">
+            <a:avLst/>
+          </a:prstGeom>
+          <a:noFill/>
+          <a:ln/>
+        </p:spPr>
+        <p:txBody>
+          <a:bodyPr wrap="square" lIns="0" tIns="0" rIns="0" bIns="0" rtlCol="0" anchor="ctr"/>
+          <a:lstStyle/>
+          <a:p>
+            <a:pPr indent="0" marL="0">
+              <a:buNone/>
+            </a:pPr>
+            <a:r>
+              <a:rPr lang="en-US" sz="1300" b="1" dirty="0">
+                <a:solidFill>
+                  <a:srgbClr val="1E293B"/>
+                </a:solidFill>
+                <a:latin typeface="Calibri" pitchFamily="34" charset="0"/>
+                <a:ea typeface="Calibri" pitchFamily="34" charset="-122"/>
+                <a:cs typeface="Calibri" pitchFamily="34" charset="-120"/>
+              </a:rPr>
+              <a:t>Google一元課金</a:t>
+            </a:r>
+            <a:endParaRPr lang="en-US" sz="1300" dirty="0"/>
+          </a:p>
+        </p:txBody>
+      </p:sp>
+      <p:sp>
+        <p:nvSpPr>
+          <p:cNvPr id="15" name="Shape 10"/>
+          <p:cNvSpPr/>
+          <p:nvPr/>
+        </p:nvSpPr>
+        <p:spPr>
+          <a:xfrm>
+            <a:off x="0" y="4754880"/>
+            <a:ext cx="9144000" cy="388620"/>
+          </a:xfrm>
+          <a:prstGeom prst="rect">
+            <a:avLst/>
+          </a:prstGeom>
+          <a:solidFill>
+            <a:srgbClr val="1E2761"/>
+          </a:solidFill>
+          <a:ln/>
+        </p:spPr>
+      </p:sp>
+      <p:sp>
+        <p:nvSpPr>
+          <p:cNvPr id="16" name="Text 11"/>
+          <p:cNvSpPr/>
+          <p:nvPr/>
+        </p:nvSpPr>
+        <p:spPr>
+          <a:xfrm>
+            <a:off x="457200" y="4754880"/>
+            <a:ext cx="8229600" cy="388620"/>
+          </a:xfrm>
+          <a:prstGeom prst="rect">
+            <a:avLst/>
+          </a:prstGeom>
+          <a:noFill/>
+          <a:ln/>
+        </p:spPr>
+        <p:txBody>
+          <a:bodyPr wrap="square" lIns="0" tIns="0" rIns="0" bIns="0" rtlCol="0" anchor="ctr"/>
+          <a:lstStyle/>
+          <a:p>
+            <a:pPr indent="0" marL="0">
+              <a:buNone/>
+            </a:pPr>
+            <a:r>
+              <a:rPr lang="en-US" sz="900" dirty="0">
+                <a:solidFill>
+                  <a:srgbClr val="CADCFC"/>
+                </a:solidFill>
+                <a:latin typeface="Calibri" pitchFamily="34" charset="0"/>
+                <a:ea typeface="Calibri" pitchFamily="34" charset="-122"/>
+                <a:cs typeface="Calibri" pitchFamily="34" charset="-120"/>
+              </a:rPr>
+              <a:t>出典: docs.cloud.google.com/gemini/enterprise/docs/register-and-manage-marketplace-agents</a:t>
+            </a:r>
+            <a:endParaRPr lang="en-US" sz="900" dirty="0"/>
+          </a:p>
+        </p:txBody>
       </p:sp>
     </p:spTree>
   </p:cSld>
@@ -8142,7 +10035,7 @@
       </p:sp>
       <p:pic>
         <p:nvPicPr>
-          <p:cNvPr id="7" name="Image 0" descr="preencoded.png">    </p:cNvPr>
+          <p:cNvPr id="7" name="Image 0" descr="preencoded.png"/>
           <p:cNvPicPr>
             <a:picLocks noChangeAspect="1"/>
           </p:cNvPicPr>
@@ -8232,7 +10125,7 @@
       </p:sp>
       <p:pic>
         <p:nvPicPr>
-          <p:cNvPr id="10" name="Image 1" descr="preencoded.png">    </p:cNvPr>
+          <p:cNvPr id="10" name="Image 1" descr="preencoded.png"/>
           <p:cNvPicPr>
             <a:picLocks noChangeAspect="1"/>
           </p:cNvPicPr>
@@ -8322,7 +10215,7 @@
       </p:sp>
       <p:pic>
         <p:nvPicPr>
-          <p:cNvPr id="13" name="Image 2" descr="preencoded.png">    </p:cNvPr>
+          <p:cNvPr id="13" name="Image 2" descr="preencoded.png"/>
           <p:cNvPicPr>
             <a:picLocks noChangeAspect="1"/>
           </p:cNvPicPr>
@@ -9465,7 +11358,7 @@
       </p:sp>
       <p:pic>
         <p:nvPicPr>
-          <p:cNvPr id="6" name="Image 0" descr="preencoded.png">    </p:cNvPr>
+          <p:cNvPr id="6" name="Image 0" descr="preencoded.png"/>
           <p:cNvPicPr>
             <a:picLocks noChangeAspect="1"/>
           </p:cNvPicPr>
@@ -9697,7 +11590,7 @@
       </p:sp>
       <p:pic>
         <p:nvPicPr>
-          <p:cNvPr id="11" name="Image 1" descr="preencoded.png">    </p:cNvPr>
+          <p:cNvPr id="11" name="Image 1" descr="preencoded.png"/>
           <p:cNvPicPr>
             <a:picLocks noChangeAspect="1"/>
           </p:cNvPicPr>
@@ -9882,7 +11775,7 @@
       </p:sp>
       <p:pic>
         <p:nvPicPr>
-          <p:cNvPr id="14" name="Image 2" descr="preencoded.png">    </p:cNvPr>
+          <p:cNvPr id="14" name="Image 2" descr="preencoded.png"/>
           <p:cNvPicPr>
             <a:picLocks noChangeAspect="1"/>
           </p:cNvPicPr>
@@ -10083,7 +11976,7 @@
       </p:sp>
       <p:pic>
         <p:nvPicPr>
-          <p:cNvPr id="5" name="Image 0" descr="preencoded.png">    </p:cNvPr>
+          <p:cNvPr id="5" name="Image 0" descr="preencoded.png"/>
           <p:cNvPicPr>
             <a:picLocks noChangeAspect="1"/>
           </p:cNvPicPr>
@@ -10184,7 +12077,7 @@
       </p:sp>
       <p:pic>
         <p:nvPicPr>
-          <p:cNvPr id="8" name="Image 1" descr="preencoded.png">    </p:cNvPr>
+          <p:cNvPr id="8" name="Image 1" descr="preencoded.png"/>
           <p:cNvPicPr>
             <a:picLocks noChangeAspect="1"/>
           </p:cNvPicPr>
@@ -10298,7 +12191,7 @@
                   <a:srgbClr val="475569"/>
                 </a:solidFill>
               </a:rPr>
-              <a:t> ServiceNow等）</a:t>
+              <a:t xml:space="preserve"> ServiceNow等）</a:t>
             </a:r>
             <a:endParaRPr lang="en-US" sz="1300" dirty="0"/>
           </a:p>
@@ -10333,7 +12226,7 @@
       </p:sp>
       <p:pic>
         <p:nvPicPr>
-          <p:cNvPr id="11" name="Image 2" descr="preencoded.png">    </p:cNvPr>
+          <p:cNvPr id="11" name="Image 2" descr="preencoded.png"/>
           <p:cNvPicPr>
             <a:picLocks noChangeAspect="1"/>
           </p:cNvPicPr>
@@ -10482,7 +12375,7 @@
       </p:sp>
       <p:pic>
         <p:nvPicPr>
-          <p:cNvPr id="14" name="Image 3" descr="preencoded.png">    </p:cNvPr>
+          <p:cNvPr id="14" name="Image 3" descr="preencoded.png"/>
           <p:cNvPicPr>
             <a:picLocks noChangeAspect="1"/>
           </p:cNvPicPr>
@@ -10907,7 +12800,7 @@
       </p:sp>
       <p:pic>
         <p:nvPicPr>
-          <p:cNvPr id="8" name="Image 0" descr="preencoded.png">    </p:cNvPr>
+          <p:cNvPr id="8" name="Image 0" descr="preencoded.png"/>
           <p:cNvPicPr>
             <a:picLocks noChangeAspect="1"/>
           </p:cNvPicPr>
@@ -11553,7 +13446,7 @@
                   <a:srgbClr val="1E2761"/>
                 </a:solidFill>
               </a:rPr>
-              <a:t>Platinum: </a:t>
+              <a:t xml:space="preserve">Platinum: </a:t>
             </a:r>
             <a:pPr indent="0" marL="0">
               <a:buNone/>
@@ -11575,7 +13468,7 @@
                   <a:srgbClr val="00A896"/>
                 </a:solidFill>
               </a:rPr>
-              <a:t>  計146組織</a:t>
+              <a:t xml:space="preserve">  計146組織</a:t>
             </a:r>
             <a:endParaRPr lang="en-US" sz="1000" dirty="0"/>
           </a:p>
@@ -11826,7 +13719,7 @@
       </p:sp>
       <p:pic>
         <p:nvPicPr>
-          <p:cNvPr id="7" name="Image 0" descr="preencoded.png">    </p:cNvPr>
+          <p:cNvPr id="7" name="Image 0" descr="preencoded.png"/>
           <p:cNvPicPr>
             <a:picLocks noChangeAspect="1"/>
           </p:cNvPicPr>
@@ -11975,7 +13868,7 @@
       </p:sp>
       <p:pic>
         <p:nvPicPr>
-          <p:cNvPr id="10" name="Image 1" descr="preencoded.png">    </p:cNvPr>
+          <p:cNvPr id="10" name="Image 1" descr="preencoded.png"/>
           <p:cNvPicPr>
             <a:picLocks noChangeAspect="1"/>
           </p:cNvPicPr>
@@ -12124,7 +14017,7 @@
       </p:sp>
       <p:pic>
         <p:nvPicPr>
-          <p:cNvPr id="13" name="Image 2" descr="preencoded.png">    </p:cNvPr>
+          <p:cNvPr id="13" name="Image 2" descr="preencoded.png"/>
           <p:cNvPicPr>
             <a:picLocks noChangeAspect="1"/>
           </p:cNvPicPr>
@@ -12287,7 +14180,7 @@
       </p:sp>
       <p:pic>
         <p:nvPicPr>
-          <p:cNvPr id="16" name="Image 3" descr="preencoded.png">    </p:cNvPr>
+          <p:cNvPr id="16" name="Image 3" descr="preencoded.png"/>
           <p:cNvPicPr>
             <a:picLocks noChangeAspect="1"/>
           </p:cNvPicPr>
@@ -14387,7 +16280,7 @@
                   <a:srgbClr val="475569"/>
                 </a:solidFill>
               </a:rPr>
-              <a:t>User Request → </a:t>
+              <a:t xml:space="preserve">User Request → </a:t>
             </a:r>
             <a:pPr algn="ctr" indent="0" marL="0">
               <a:buNone/>
@@ -14412,7 +16305,7 @@
                   <a:srgbClr val="475569"/>
                 </a:solidFill>
               </a:rPr>
-              <a:t> → AI Model → </a:t>
+              <a:t xml:space="preserve"> → AI Model → </a:t>
             </a:r>
             <a:pPr algn="ctr" indent="0" marL="0">
               <a:buNone/>
@@ -14437,7 +16330,7 @@
                   <a:srgbClr val="475569"/>
                 </a:solidFill>
               </a:rPr>
-              <a:t> → Safe Response</a:t>
+              <a:t xml:space="preserve"> → Safe Response</a:t>
             </a:r>
             <a:endParaRPr lang="en-US" sz="1100" dirty="0"/>
           </a:p>
@@ -14492,7 +16385,7 @@
       </p:sp>
       <p:pic>
         <p:nvPicPr>
-          <p:cNvPr id="10" name="Image 0" descr="preencoded.png">    </p:cNvPr>
+          <p:cNvPr id="10" name="Image 0" descr="preencoded.png"/>
           <p:cNvPicPr>
             <a:picLocks noChangeAspect="1"/>
           </p:cNvPicPr>
@@ -14675,7 +16568,7 @@
       </p:sp>
       <p:pic>
         <p:nvPicPr>
-          <p:cNvPr id="14" name="Image 1" descr="preencoded.png">    </p:cNvPr>
+          <p:cNvPr id="14" name="Image 1" descr="preencoded.png"/>
           <p:cNvPicPr>
             <a:picLocks noChangeAspect="1"/>
           </p:cNvPicPr>
@@ -14858,7 +16751,7 @@
       </p:sp>
       <p:pic>
         <p:nvPicPr>
-          <p:cNvPr id="18" name="Image 2" descr="preencoded.png">    </p:cNvPr>
+          <p:cNvPr id="18" name="Image 2" descr="preencoded.png"/>
           <p:cNvPicPr>
             <a:picLocks noChangeAspect="1"/>
           </p:cNvPicPr>
@@ -15041,7 +16934,7 @@
       </p:sp>
       <p:pic>
         <p:nvPicPr>
-          <p:cNvPr id="22" name="Image 3" descr="preencoded.png">    </p:cNvPr>
+          <p:cNvPr id="22" name="Image 3" descr="preencoded.png"/>
           <p:cNvPicPr>
             <a:picLocks noChangeAspect="1"/>
           </p:cNvPicPr>
@@ -15224,7 +17117,7 @@
       </p:sp>
       <p:pic>
         <p:nvPicPr>
-          <p:cNvPr id="26" name="Image 4" descr="preencoded.png">    </p:cNvPr>
+          <p:cNvPr id="26" name="Image 4" descr="preencoded.png"/>
           <p:cNvPicPr>
             <a:picLocks noChangeAspect="1"/>
           </p:cNvPicPr>

</xml_diff>